<commit_message>
Marketing refresh: AI Draft + Organizations across all collateral
Updates the messaging to lead with the two headline features shipped:
- AI Draft — 'AI drafts the whole proposal from your quote, in your brand voice'
  (replaces the old 'Gemini writing assistant' framing; Ask AI + pricing extraction
  kept as secondary).
- Organizations / white-label — new brochure + deck feature; woven into the
  one-pager/beta/deck subtitles ('for one team or a whole organization').

Files: brochure + one-pager HTML (+ regenerated PDFs via headless Chrome), the
pitch-deck generator build-deck.js (+ regenerated .pptx), and the live /beta
landing page (app/beta/beta-client.tsx) which mirrors the one-pager. Pricing
untouched (frozen). type-check clean.

Co-Authored-By: Claude Opus 4.8 <noreply@anthropic.com>
</commit_message>
<xml_diff>
--- a/marketing-materials/ultraquote-deck.pptx
+++ b/marketing-materials/ultraquote-deck.pptx
@@ -1685,7 +1685,7 @@
                 <a:ea typeface="Calibri" pitchFamily="34" charset="-122"/>
                 <a:cs typeface="Calibri" pitchFamily="34" charset="-120"/>
               </a:rPr>
-              <a:t>The all-in-one platform for any team that sends quotes — build multi-option quotes, write polished proposals with AI, and collect legally-binding e-signatures, without leaving the app.</a:t>
+              <a:t>The all-in-one platform for any team that sends quotes — build multi-option quotes, let AI draft polished proposals in your brand voice, and collect legally-binding e-signatures — for one team or a whole organization.</a:t>
             </a:r>
             <a:endParaRPr lang="en-US" sz="1600" dirty="0"/>
           </a:p>
@@ -3036,7 +3036,7 @@
                 <a:ea typeface="Calibri" pitchFamily="34" charset="-122"/>
                 <a:cs typeface="Calibri" pitchFamily="34" charset="-120"/>
               </a:rPr>
-              <a:t>A rich proposal editor with your branding, AI writing assistance, two-column layouts, and embedded live pricing.</a:t>
+              <a:t>AI drafts the whole proposal from your quote, in your brand voice — in a rich editor with your branding, two-column layouts, and live pricing.</a:t>
             </a:r>
             <a:endParaRPr lang="en-US" sz="1300" dirty="0"/>
           </a:p>
@@ -3645,7 +3645,7 @@
                 <a:ea typeface="Georgia" pitchFamily="34" charset="-122"/>
                 <a:cs typeface="Georgia" pitchFamily="34" charset="-120"/>
               </a:rPr>
-              <a:t>AI writing assistant</a:t>
+              <a:t>AI proposal drafting</a:t>
             </a:r>
             <a:endParaRPr lang="en-US" sz="1500" dirty="0"/>
           </a:p>
@@ -3684,7 +3684,7 @@
                 <a:ea typeface="Calibri" pitchFamily="34" charset="-122"/>
                 <a:cs typeface="Calibri" pitchFamily="34" charset="-120"/>
               </a:rPr>
-              <a:t>Google Gemini drafts, expands, re-tones &amp; extracts pricing from docs.</a:t>
+              <a:t>Draft a full proposal from your quote in your brand voice; edit the outline. Plus inline Ask AI.</a:t>
             </a:r>
             <a:endParaRPr lang="en-US" sz="1150" dirty="0"/>
           </a:p>
@@ -4137,7 +4137,7 @@
                 <a:ea typeface="Georgia" pitchFamily="34" charset="-122"/>
                 <a:cs typeface="Georgia" pitchFamily="34" charset="-120"/>
               </a:rPr>
-              <a:t>Teams &amp; roles</a:t>
+              <a:t>Teams, roles &amp; orgs</a:t>
             </a:r>
             <a:endParaRPr lang="en-US" sz="1500" dirty="0"/>
           </a:p>
@@ -4176,7 +4176,7 @@
                 <a:ea typeface="Calibri" pitchFamily="34" charset="-122"/>
                 <a:cs typeface="Calibri" pitchFamily="34" charset="-120"/>
               </a:rPr>
-              <a:t>Owner/member roles, quote ownership, and live presence indicators.</a:t>
+              <a:t>Owner/member roles, quote ownership, presence — and multi-workspace Organizations.</a:t>
             </a:r>
             <a:endParaRPr lang="en-US" sz="1150" dirty="0"/>
           </a:p>
@@ -4816,7 +4816,7 @@
                 <a:ea typeface="Calibri" pitchFamily="34" charset="-122"/>
                 <a:cs typeface="Calibri" pitchFamily="34" charset="-120"/>
               </a:rPr>
-              <a:t>Draft with AI, drop in live pricing tables, and brand the document.</a:t>
+              <a:t>Let AI draft it in your brand voice; drop in live pricing; brand it.</a:t>
             </a:r>
             <a:endParaRPr lang="en-US" sz="1200" dirty="0"/>
           </a:p>

</xml_diff>

<commit_message>
Marketing refresh: AI Draft + Organizations across all collateral (#15)
Updates the messaging to lead with the two headline features shipped:
- AI Draft — 'AI drafts the whole proposal from your quote, in your brand voice'
  (replaces the old 'Gemini writing assistant' framing; Ask AI + pricing extraction
  kept as secondary).
- Organizations / white-label — new brochure + deck feature; woven into the
  one-pager/beta/deck subtitles ('for one team or a whole organization').

Files: brochure + one-pager HTML (+ regenerated PDFs via headless Chrome), the
pitch-deck generator build-deck.js (+ regenerated .pptx), and the live /beta
landing page (app/beta/beta-client.tsx) which mirrors the one-pager. Pricing
untouched (frozen). type-check clean.

Co-authored-by: Sameer Pandya <sameer@ultraedge.us>
Co-authored-by: Claude Opus 4.8 <noreply@anthropic.com>
</commit_message>
<xml_diff>
--- a/marketing-materials/ultraquote-deck.pptx
+++ b/marketing-materials/ultraquote-deck.pptx
@@ -1685,7 +1685,7 @@
                 <a:ea typeface="Calibri" pitchFamily="34" charset="-122"/>
                 <a:cs typeface="Calibri" pitchFamily="34" charset="-120"/>
               </a:rPr>
-              <a:t>The all-in-one platform for any team that sends quotes — build multi-option quotes, write polished proposals with AI, and collect legally-binding e-signatures, without leaving the app.</a:t>
+              <a:t>The all-in-one platform for any team that sends quotes — build multi-option quotes, let AI draft polished proposals in your brand voice, and collect legally-binding e-signatures — for one team or a whole organization.</a:t>
             </a:r>
             <a:endParaRPr lang="en-US" sz="1600" dirty="0"/>
           </a:p>
@@ -3036,7 +3036,7 @@
                 <a:ea typeface="Calibri" pitchFamily="34" charset="-122"/>
                 <a:cs typeface="Calibri" pitchFamily="34" charset="-120"/>
               </a:rPr>
-              <a:t>A rich proposal editor with your branding, AI writing assistance, two-column layouts, and embedded live pricing.</a:t>
+              <a:t>AI drafts the whole proposal from your quote, in your brand voice — in a rich editor with your branding, two-column layouts, and live pricing.</a:t>
             </a:r>
             <a:endParaRPr lang="en-US" sz="1300" dirty="0"/>
           </a:p>
@@ -3645,7 +3645,7 @@
                 <a:ea typeface="Georgia" pitchFamily="34" charset="-122"/>
                 <a:cs typeface="Georgia" pitchFamily="34" charset="-120"/>
               </a:rPr>
-              <a:t>AI writing assistant</a:t>
+              <a:t>AI proposal drafting</a:t>
             </a:r>
             <a:endParaRPr lang="en-US" sz="1500" dirty="0"/>
           </a:p>
@@ -3684,7 +3684,7 @@
                 <a:ea typeface="Calibri" pitchFamily="34" charset="-122"/>
                 <a:cs typeface="Calibri" pitchFamily="34" charset="-120"/>
               </a:rPr>
-              <a:t>Google Gemini drafts, expands, re-tones &amp; extracts pricing from docs.</a:t>
+              <a:t>Draft a full proposal from your quote in your brand voice; edit the outline. Plus inline Ask AI.</a:t>
             </a:r>
             <a:endParaRPr lang="en-US" sz="1150" dirty="0"/>
           </a:p>
@@ -4137,7 +4137,7 @@
                 <a:ea typeface="Georgia" pitchFamily="34" charset="-122"/>
                 <a:cs typeface="Georgia" pitchFamily="34" charset="-120"/>
               </a:rPr>
-              <a:t>Teams &amp; roles</a:t>
+              <a:t>Teams, roles &amp; orgs</a:t>
             </a:r>
             <a:endParaRPr lang="en-US" sz="1500" dirty="0"/>
           </a:p>
@@ -4176,7 +4176,7 @@
                 <a:ea typeface="Calibri" pitchFamily="34" charset="-122"/>
                 <a:cs typeface="Calibri" pitchFamily="34" charset="-120"/>
               </a:rPr>
-              <a:t>Owner/member roles, quote ownership, and live presence indicators.</a:t>
+              <a:t>Owner/member roles, quote ownership, presence — and multi-workspace Organizations.</a:t>
             </a:r>
             <a:endParaRPr lang="en-US" sz="1150" dirty="0"/>
           </a:p>
@@ -4816,7 +4816,7 @@
                 <a:ea typeface="Calibri" pitchFamily="34" charset="-122"/>
                 <a:cs typeface="Calibri" pitchFamily="34" charset="-120"/>
               </a:rPr>
-              <a:t>Draft with AI, drop in live pricing tables, and brand the document.</a:t>
+              <a:t>Let AI draft it in your brand voice; drop in live pricing; brand it.</a:t>
             </a:r>
             <a:endParaRPr lang="en-US" sz="1200" dirty="0"/>
           </a:p>

</xml_diff>

<commit_message>
Deck: add a dedicated AI Draft spotlight slide
The pitch deck only mentioned AI Draft as one tile among nine features. Add a
dedicated spotlight slide (now slide 5 of 8) showing the flagship's depth:
Intake -> Outline -> Draft flow, grounded in the quote (never invents numbers),
writes in your Proposal Voice, uses private Client Notes, ends with an e-sign CTA,
preview-before-insert, plus inline Ask AI. Regenerated ultraquote-deck.pptx.

Co-Authored-By: Claude Opus 4.8 <noreply@anthropic.com>
</commit_message>
<xml_diff>
--- a/marketing-materials/ultraquote-deck.pptx
+++ b/marketing-materials/ultraquote-deck.pptx
@@ -12,9 +12,10 @@
     <p:sldId id="260" r:id="rId6"/>
     <p:sldId id="261" r:id="rId7"/>
     <p:sldId id="262" r:id="rId8"/>
+    <p:sldId id="263" r:id="rId9"/>
   </p:sldIdLst>
   <p:notesMasterIdLst>
-    <p:notesMasterId r:id="rId9"/>
+    <p:notesMasterId r:id="rId10"/>
   </p:notesMasterIdLst>
   <p:sldSz cx="12192000" cy="6858000"/>
   <p:notesSz cx="6858000" cy="12192000"/>
@@ -1060,6 +1061,94 @@
             <a:fld id="{F7021451-1387-4CA6-816F-3879F97B5CBC}" type="slidenum">
               <a:rPr lang="en-US"/>
               <a:t>7</a:t>
+            </a:fld>
+            <a:endParaRPr lang="en-US"/>
+          </a:p>
+        </p:txBody>
+      </p:sp>
+    </p:spTree>
+    <p:extLst>
+      <p:ext uri="{BB962C8B-B14F-4D97-AF65-F5344CB8AC3E}">
+        <p14:creationId xmlns:p14="http://schemas.microsoft.com/office/powerpoint/2010/main" val="1024086991"/>
+      </p:ext>
+    </p:extLst>
+  </p:cSld>
+  <p:clrMapOvr>
+    <a:masterClrMapping/>
+  </p:clrMapOvr>
+</p:notes>
+</file>
+
+<file path=ppt/notesSlides/notesSlide8.xml><?xml version="1.0" encoding="utf-8"?>
+<p:notes xmlns:a="http://schemas.openxmlformats.org/drawingml/2006/main" xmlns:r="http://schemas.openxmlformats.org/officeDocument/2006/relationships" xmlns:p="http://schemas.openxmlformats.org/presentationml/2006/main">
+  <p:cSld>
+    <p:spTree>
+      <p:nvGrpSpPr>
+        <p:cNvPr id="1" name=""/>
+        <p:cNvGrpSpPr/>
+        <p:nvPr/>
+      </p:nvGrpSpPr>
+      <p:grpSpPr>
+        <a:xfrm>
+          <a:off x="0" y="0"/>
+          <a:ext cx="0" cy="0"/>
+          <a:chOff x="0" y="0"/>
+          <a:chExt cx="0" cy="0"/>
+        </a:xfrm>
+      </p:grpSpPr>
+      <p:sp>
+        <p:nvSpPr>
+          <p:cNvPr id="2" name="Slide Image Placeholder 1"/>
+          <p:cNvSpPr>
+            <a:spLocks noGrp="1" noRot="1" noChangeAspect="1"/>
+          </p:cNvSpPr>
+          <p:nvPr>
+            <p:ph type="sldImg"/>
+          </p:nvPr>
+        </p:nvSpPr>
+        <p:spPr/>
+      </p:sp>
+      <p:sp>
+        <p:nvSpPr>
+          <p:cNvPr id="3" name="Notes Placeholder 2"/>
+          <p:cNvSpPr>
+            <a:spLocks noGrp="1"/>
+          </p:cNvSpPr>
+          <p:nvPr>
+            <p:ph type="body" idx="1"/>
+          </p:nvPr>
+        </p:nvSpPr>
+        <p:spPr/>
+        <p:txBody>
+          <a:bodyPr/>
+          <a:lstStyle/>
+          <a:p>
+            <a:r>
+              <a:rPr lang="en-US" dirty="0"/>
+              <a:t/>
+            </a:r>
+            <a:endParaRPr lang="en-US" dirty="0"/>
+          </a:p>
+        </p:txBody>
+      </p:sp>
+      <p:sp>
+        <p:nvSpPr>
+          <p:cNvPr id="4" name="Slide Number Placeholder 3"/>
+          <p:cNvSpPr>
+            <a:spLocks noGrp="1"/>
+          </p:cNvSpPr>
+          <p:nvPr>
+            <p:ph type="sldNum" sz="quarter" idx="10"/>
+          </p:nvPr>
+        </p:nvSpPr>
+        <p:spPr/>
+        <p:txBody>
+          <a:bodyPr/>
+          <a:lstStyle/>
+          <a:p>
+            <a:fld id="{F7021451-1387-4CA6-816F-3879F97B5CBC}" type="slidenum">
+              <a:rPr lang="en-US"/>
+              <a:t>8</a:t>
             </a:fld>
             <a:endParaRPr lang="en-US"/>
           </a:p>
@@ -4442,6 +4531,874 @@
     <p:bg>
       <p:bgPr>
         <a:solidFill>
+          <a:srgbClr val="EFF6FF"/>
+        </a:solidFill>
+      </p:bgPr>
+    </p:bg>
+    <p:spTree>
+      <p:nvGrpSpPr>
+        <p:cNvPr id="1" name=""/>
+        <p:cNvGrpSpPr/>
+        <p:nvPr/>
+      </p:nvGrpSpPr>
+      <p:grpSpPr>
+        <a:xfrm>
+          <a:off x="0" y="0"/>
+          <a:ext cx="0" cy="0"/>
+          <a:chOff x="0" y="0"/>
+          <a:chExt cx="0" cy="0"/>
+        </a:xfrm>
+      </p:grpSpPr>
+      <p:sp>
+        <p:nvSpPr>
+          <p:cNvPr id="2" name="Text 0"/>
+          <p:cNvSpPr/>
+          <p:nvPr/>
+        </p:nvSpPr>
+        <p:spPr>
+          <a:xfrm>
+            <a:off x="822960" y="502920"/>
+            <a:ext cx="7315200" cy="274320"/>
+          </a:xfrm>
+          <a:prstGeom prst="rect">
+            <a:avLst/>
+          </a:prstGeom>
+          <a:noFill/>
+          <a:ln/>
+        </p:spPr>
+        <p:txBody>
+          <a:bodyPr wrap="square" lIns="0" tIns="0" rIns="0" bIns="0" rtlCol="0" anchor="ctr"/>
+          <a:lstStyle/>
+          <a:p>
+            <a:pPr indent="0" marL="0">
+              <a:buNone/>
+            </a:pPr>
+            <a:r>
+              <a:rPr lang="en-US" sz="1200" b="1" spc="200" kern="0" dirty="0">
+                <a:solidFill>
+                  <a:srgbClr val="0F5F5C"/>
+                </a:solidFill>
+                <a:latin typeface="Calibri" pitchFamily="34" charset="0"/>
+                <a:ea typeface="Calibri" pitchFamily="34" charset="-122"/>
+                <a:cs typeface="Calibri" pitchFamily="34" charset="-120"/>
+              </a:rPr>
+              <a:t>FEATURED · AI PROPOSAL DRAFTING</a:t>
+            </a:r>
+            <a:endParaRPr lang="en-US" sz="1200" dirty="0"/>
+          </a:p>
+        </p:txBody>
+      </p:sp>
+      <p:sp>
+        <p:nvSpPr>
+          <p:cNvPr id="3" name="Text 1"/>
+          <p:cNvSpPr/>
+          <p:nvPr/>
+        </p:nvSpPr>
+        <p:spPr>
+          <a:xfrm>
+            <a:off x="822960" y="822960"/>
+            <a:ext cx="10515600" cy="731520"/>
+          </a:xfrm>
+          <a:prstGeom prst="rect">
+            <a:avLst/>
+          </a:prstGeom>
+          <a:noFill/>
+          <a:ln/>
+        </p:spPr>
+        <p:txBody>
+          <a:bodyPr wrap="square" lIns="0" tIns="0" rIns="0" bIns="0" rtlCol="0" anchor="ctr"/>
+          <a:lstStyle/>
+          <a:p>
+            <a:pPr indent="0" marL="0">
+              <a:buNone/>
+            </a:pPr>
+            <a:r>
+              <a:rPr lang="en-US" sz="3000" b="1" dirty="0">
+                <a:solidFill>
+                  <a:srgbClr val="0B1F3A"/>
+                </a:solidFill>
+                <a:latin typeface="Georgia" pitchFamily="34" charset="0"/>
+                <a:ea typeface="Georgia" pitchFamily="34" charset="-122"/>
+                <a:cs typeface="Georgia" pitchFamily="34" charset="-120"/>
+              </a:rPr>
+              <a:t>Let AI draft the whole proposal — in your voice.</a:t>
+            </a:r>
+            <a:endParaRPr lang="en-US" sz="3000" dirty="0"/>
+          </a:p>
+        </p:txBody>
+      </p:sp>
+      <p:sp>
+        <p:nvSpPr>
+          <p:cNvPr id="4" name="Text 2"/>
+          <p:cNvSpPr/>
+          <p:nvPr/>
+        </p:nvSpPr>
+        <p:spPr>
+          <a:xfrm>
+            <a:off x="822960" y="1572768"/>
+            <a:ext cx="10424160" cy="548640"/>
+          </a:xfrm>
+          <a:prstGeom prst="rect">
+            <a:avLst/>
+          </a:prstGeom>
+          <a:noFill/>
+          <a:ln/>
+        </p:spPr>
+        <p:txBody>
+          <a:bodyPr wrap="square" lIns="0" tIns="0" rIns="0" bIns="0" rtlCol="0" anchor="ctr"/>
+          <a:lstStyle/>
+          <a:p>
+            <a:pPr indent="0" marL="0">
+              <a:buNone/>
+            </a:pPr>
+            <a:r>
+              <a:rPr lang="en-US" sz="1500" dirty="0">
+                <a:solidFill>
+                  <a:srgbClr val="64748B"/>
+                </a:solidFill>
+                <a:latin typeface="Calibri" pitchFamily="34" charset="0"/>
+                <a:ea typeface="Calibri" pitchFamily="34" charset="-122"/>
+                <a:cs typeface="Calibri" pitchFamily="34" charset="-120"/>
+              </a:rPr>
+              <a:t>Grounded in your quote's own services, pricing, and client — the AI never invents numbers, and you review every word before it's inserted.</a:t>
+            </a:r>
+            <a:endParaRPr lang="en-US" sz="1500" dirty="0"/>
+          </a:p>
+        </p:txBody>
+      </p:sp>
+      <p:sp>
+        <p:nvSpPr>
+          <p:cNvPr id="5" name="Shape 3"/>
+          <p:cNvSpPr/>
+          <p:nvPr/>
+        </p:nvSpPr>
+        <p:spPr>
+          <a:xfrm>
+            <a:off x="822960" y="2514600"/>
+            <a:ext cx="3383280" cy="1737360"/>
+          </a:xfrm>
+          <a:prstGeom prst="rect">
+            <a:avLst/>
+          </a:prstGeom>
+          <a:solidFill>
+            <a:srgbClr val="FFFFFF"/>
+          </a:solidFill>
+          <a:ln w="12700">
+            <a:solidFill>
+              <a:srgbClr val="E2E8F0"/>
+            </a:solidFill>
+            <a:prstDash val="solid"/>
+          </a:ln>
+          <a:effectLst>
+            <a:outerShdw sx="100000" sy="100000" kx="0" ky="0" algn="bl" rotWithShape="0" blurRad="114300" dist="38100" dir="8100000">
+              <a:srgbClr val="0F172A">
+                <a:alpha val="12000"/>
+              </a:srgbClr>
+            </a:outerShdw>
+          </a:effectLst>
+        </p:spPr>
+      </p:sp>
+      <p:sp>
+        <p:nvSpPr>
+          <p:cNvPr id="6" name="Shape 4"/>
+          <p:cNvSpPr/>
+          <p:nvPr/>
+        </p:nvSpPr>
+        <p:spPr>
+          <a:xfrm>
+            <a:off x="822960" y="2514600"/>
+            <a:ext cx="3383280" cy="82296"/>
+          </a:xfrm>
+          <a:prstGeom prst="rect">
+            <a:avLst/>
+          </a:prstGeom>
+          <a:solidFill>
+            <a:srgbClr val="0EA5A4"/>
+          </a:solidFill>
+          <a:ln/>
+        </p:spPr>
+      </p:sp>
+      <p:sp>
+        <p:nvSpPr>
+          <p:cNvPr id="7" name="Text 5"/>
+          <p:cNvSpPr/>
+          <p:nvPr/>
+        </p:nvSpPr>
+        <p:spPr>
+          <a:xfrm>
+            <a:off x="1078992" y="2743200"/>
+            <a:ext cx="2926080" cy="365760"/>
+          </a:xfrm>
+          <a:prstGeom prst="rect">
+            <a:avLst/>
+          </a:prstGeom>
+          <a:noFill/>
+          <a:ln/>
+        </p:spPr>
+        <p:txBody>
+          <a:bodyPr wrap="square" lIns="0" tIns="0" rIns="0" bIns="0" rtlCol="0" anchor="ctr"/>
+          <a:lstStyle/>
+          <a:p>
+            <a:pPr indent="0" marL="0">
+              <a:buNone/>
+            </a:pPr>
+            <a:r>
+              <a:rPr lang="en-US" sz="1700" b="1" dirty="0">
+                <a:solidFill>
+                  <a:srgbClr val="1D4ED8"/>
+                </a:solidFill>
+                <a:latin typeface="Georgia" pitchFamily="34" charset="0"/>
+                <a:ea typeface="Georgia" pitchFamily="34" charset="-122"/>
+                <a:cs typeface="Georgia" pitchFamily="34" charset="-120"/>
+              </a:rPr>
+              <a:t>1 · Intake</a:t>
+            </a:r>
+            <a:endParaRPr lang="en-US" sz="1700" dirty="0"/>
+          </a:p>
+        </p:txBody>
+      </p:sp>
+      <p:sp>
+        <p:nvSpPr>
+          <p:cNvPr id="8" name="Text 6"/>
+          <p:cNvSpPr/>
+          <p:nvPr/>
+        </p:nvSpPr>
+        <p:spPr>
+          <a:xfrm>
+            <a:off x="1078992" y="3200400"/>
+            <a:ext cx="2971800" cy="960120"/>
+          </a:xfrm>
+          <a:prstGeom prst="rect">
+            <a:avLst/>
+          </a:prstGeom>
+          <a:noFill/>
+          <a:ln/>
+        </p:spPr>
+        <p:txBody>
+          <a:bodyPr wrap="square" lIns="0" tIns="0" rIns="0" bIns="0" rtlCol="0" anchor="ctr"/>
+          <a:lstStyle/>
+          <a:p>
+            <a:pPr indent="0" marL="0">
+              <a:buNone/>
+            </a:pPr>
+            <a:r>
+              <a:rPr lang="en-US" sz="1250" dirty="0">
+                <a:solidFill>
+                  <a:srgbClr val="64748B"/>
+                </a:solidFill>
+                <a:latin typeface="Calibri" pitchFamily="34" charset="0"/>
+                <a:ea typeface="Calibri" pitchFamily="34" charset="-122"/>
+                <a:cs typeface="Calibri" pitchFamily="34" charset="-120"/>
+              </a:rPr>
+              <a:t>Set the style — tone, length, emphasis. Optionally reference a past proposal to match.</a:t>
+            </a:r>
+            <a:endParaRPr lang="en-US" sz="1250" dirty="0"/>
+          </a:p>
+        </p:txBody>
+      </p:sp>
+      <p:sp>
+        <p:nvSpPr>
+          <p:cNvPr id="9" name="Text 7"/>
+          <p:cNvSpPr/>
+          <p:nvPr/>
+        </p:nvSpPr>
+        <p:spPr>
+          <a:xfrm>
+            <a:off x="4206240" y="3154680"/>
+            <a:ext cx="384048" cy="457200"/>
+          </a:xfrm>
+          <a:prstGeom prst="rect">
+            <a:avLst/>
+          </a:prstGeom>
+          <a:noFill/>
+          <a:ln/>
+        </p:spPr>
+        <p:txBody>
+          <a:bodyPr wrap="square" lIns="0" tIns="0" rIns="0" bIns="0" rtlCol="0" anchor="ctr"/>
+          <a:lstStyle/>
+          <a:p>
+            <a:pPr algn="ctr" indent="0" marL="0">
+              <a:buNone/>
+            </a:pPr>
+            <a:r>
+              <a:rPr lang="en-US" sz="2200" b="1" dirty="0">
+                <a:solidFill>
+                  <a:srgbClr val="0EA5A4"/>
+                </a:solidFill>
+                <a:latin typeface="Calibri" pitchFamily="34" charset="0"/>
+                <a:ea typeface="Calibri" pitchFamily="34" charset="-122"/>
+                <a:cs typeface="Calibri" pitchFamily="34" charset="-120"/>
+              </a:rPr>
+              <a:t>→</a:t>
+            </a:r>
+            <a:endParaRPr lang="en-US" sz="2200" dirty="0"/>
+          </a:p>
+        </p:txBody>
+      </p:sp>
+      <p:sp>
+        <p:nvSpPr>
+          <p:cNvPr id="10" name="Shape 8"/>
+          <p:cNvSpPr/>
+          <p:nvPr/>
+        </p:nvSpPr>
+        <p:spPr>
+          <a:xfrm>
+            <a:off x="4526280" y="2514600"/>
+            <a:ext cx="3383280" cy="1737360"/>
+          </a:xfrm>
+          <a:prstGeom prst="rect">
+            <a:avLst/>
+          </a:prstGeom>
+          <a:solidFill>
+            <a:srgbClr val="FFFFFF"/>
+          </a:solidFill>
+          <a:ln w="12700">
+            <a:solidFill>
+              <a:srgbClr val="E2E8F0"/>
+            </a:solidFill>
+            <a:prstDash val="solid"/>
+          </a:ln>
+          <a:effectLst>
+            <a:outerShdw sx="100000" sy="100000" kx="0" ky="0" algn="bl" rotWithShape="0" blurRad="114300" dist="38100" dir="8100000">
+              <a:srgbClr val="0F172A">
+                <a:alpha val="12000"/>
+              </a:srgbClr>
+            </a:outerShdw>
+          </a:effectLst>
+        </p:spPr>
+      </p:sp>
+      <p:sp>
+        <p:nvSpPr>
+          <p:cNvPr id="11" name="Shape 9"/>
+          <p:cNvSpPr/>
+          <p:nvPr/>
+        </p:nvSpPr>
+        <p:spPr>
+          <a:xfrm>
+            <a:off x="4526280" y="2514600"/>
+            <a:ext cx="3383280" cy="82296"/>
+          </a:xfrm>
+          <a:prstGeom prst="rect">
+            <a:avLst/>
+          </a:prstGeom>
+          <a:solidFill>
+            <a:srgbClr val="0EA5A4"/>
+          </a:solidFill>
+          <a:ln/>
+        </p:spPr>
+      </p:sp>
+      <p:sp>
+        <p:nvSpPr>
+          <p:cNvPr id="12" name="Text 10"/>
+          <p:cNvSpPr/>
+          <p:nvPr/>
+        </p:nvSpPr>
+        <p:spPr>
+          <a:xfrm>
+            <a:off x="4782312" y="2743200"/>
+            <a:ext cx="2926080" cy="365760"/>
+          </a:xfrm>
+          <a:prstGeom prst="rect">
+            <a:avLst/>
+          </a:prstGeom>
+          <a:noFill/>
+          <a:ln/>
+        </p:spPr>
+        <p:txBody>
+          <a:bodyPr wrap="square" lIns="0" tIns="0" rIns="0" bIns="0" rtlCol="0" anchor="ctr"/>
+          <a:lstStyle/>
+          <a:p>
+            <a:pPr indent="0" marL="0">
+              <a:buNone/>
+            </a:pPr>
+            <a:r>
+              <a:rPr lang="en-US" sz="1700" b="1" dirty="0">
+                <a:solidFill>
+                  <a:srgbClr val="1D4ED8"/>
+                </a:solidFill>
+                <a:latin typeface="Georgia" pitchFamily="34" charset="0"/>
+                <a:ea typeface="Georgia" pitchFamily="34" charset="-122"/>
+                <a:cs typeface="Georgia" pitchFamily="34" charset="-120"/>
+              </a:rPr>
+              <a:t>2 · Outline</a:t>
+            </a:r>
+            <a:endParaRPr lang="en-US" sz="1700" dirty="0"/>
+          </a:p>
+        </p:txBody>
+      </p:sp>
+      <p:sp>
+        <p:nvSpPr>
+          <p:cNvPr id="13" name="Text 11"/>
+          <p:cNvSpPr/>
+          <p:nvPr/>
+        </p:nvSpPr>
+        <p:spPr>
+          <a:xfrm>
+            <a:off x="4782312" y="3200400"/>
+            <a:ext cx="2971800" cy="960120"/>
+          </a:xfrm>
+          <a:prstGeom prst="rect">
+            <a:avLst/>
+          </a:prstGeom>
+          <a:noFill/>
+          <a:ln/>
+        </p:spPr>
+        <p:txBody>
+          <a:bodyPr wrap="square" lIns="0" tIns="0" rIns="0" bIns="0" rtlCol="0" anchor="ctr"/>
+          <a:lstStyle/>
+          <a:p>
+            <a:pPr indent="0" marL="0">
+              <a:buNone/>
+            </a:pPr>
+            <a:r>
+              <a:rPr lang="en-US" sz="1250" dirty="0">
+                <a:solidFill>
+                  <a:srgbClr val="64748B"/>
+                </a:solidFill>
+                <a:latin typeface="Calibri" pitchFamily="34" charset="0"/>
+                <a:ea typeface="Calibri" pitchFamily="34" charset="-122"/>
+                <a:cs typeface="Calibri" pitchFamily="34" charset="-120"/>
+              </a:rPr>
+              <a:t>AI proposes a section outline tailored to the deal. Rename, reorder, add, or remove.</a:t>
+            </a:r>
+            <a:endParaRPr lang="en-US" sz="1250" dirty="0"/>
+          </a:p>
+        </p:txBody>
+      </p:sp>
+      <p:sp>
+        <p:nvSpPr>
+          <p:cNvPr id="14" name="Text 12"/>
+          <p:cNvSpPr/>
+          <p:nvPr/>
+        </p:nvSpPr>
+        <p:spPr>
+          <a:xfrm>
+            <a:off x="7909560" y="3154680"/>
+            <a:ext cx="384048" cy="457200"/>
+          </a:xfrm>
+          <a:prstGeom prst="rect">
+            <a:avLst/>
+          </a:prstGeom>
+          <a:noFill/>
+          <a:ln/>
+        </p:spPr>
+        <p:txBody>
+          <a:bodyPr wrap="square" lIns="0" tIns="0" rIns="0" bIns="0" rtlCol="0" anchor="ctr"/>
+          <a:lstStyle/>
+          <a:p>
+            <a:pPr algn="ctr" indent="0" marL="0">
+              <a:buNone/>
+            </a:pPr>
+            <a:r>
+              <a:rPr lang="en-US" sz="2200" b="1" dirty="0">
+                <a:solidFill>
+                  <a:srgbClr val="0EA5A4"/>
+                </a:solidFill>
+                <a:latin typeface="Calibri" pitchFamily="34" charset="0"/>
+                <a:ea typeface="Calibri" pitchFamily="34" charset="-122"/>
+                <a:cs typeface="Calibri" pitchFamily="34" charset="-120"/>
+              </a:rPr>
+              <a:t>→</a:t>
+            </a:r>
+            <a:endParaRPr lang="en-US" sz="2200" dirty="0"/>
+          </a:p>
+        </p:txBody>
+      </p:sp>
+      <p:sp>
+        <p:nvSpPr>
+          <p:cNvPr id="15" name="Shape 13"/>
+          <p:cNvSpPr/>
+          <p:nvPr/>
+        </p:nvSpPr>
+        <p:spPr>
+          <a:xfrm>
+            <a:off x="8229600" y="2514600"/>
+            <a:ext cx="3383280" cy="1737360"/>
+          </a:xfrm>
+          <a:prstGeom prst="rect">
+            <a:avLst/>
+          </a:prstGeom>
+          <a:solidFill>
+            <a:srgbClr val="FFFFFF"/>
+          </a:solidFill>
+          <a:ln w="12700">
+            <a:solidFill>
+              <a:srgbClr val="E2E8F0"/>
+            </a:solidFill>
+            <a:prstDash val="solid"/>
+          </a:ln>
+          <a:effectLst>
+            <a:outerShdw sx="100000" sy="100000" kx="0" ky="0" algn="bl" rotWithShape="0" blurRad="114300" dist="38100" dir="8100000">
+              <a:srgbClr val="0F172A">
+                <a:alpha val="12000"/>
+              </a:srgbClr>
+            </a:outerShdw>
+          </a:effectLst>
+        </p:spPr>
+      </p:sp>
+      <p:sp>
+        <p:nvSpPr>
+          <p:cNvPr id="16" name="Shape 14"/>
+          <p:cNvSpPr/>
+          <p:nvPr/>
+        </p:nvSpPr>
+        <p:spPr>
+          <a:xfrm>
+            <a:off x="8229600" y="2514600"/>
+            <a:ext cx="3383280" cy="82296"/>
+          </a:xfrm>
+          <a:prstGeom prst="rect">
+            <a:avLst/>
+          </a:prstGeom>
+          <a:solidFill>
+            <a:srgbClr val="0EA5A4"/>
+          </a:solidFill>
+          <a:ln/>
+        </p:spPr>
+      </p:sp>
+      <p:sp>
+        <p:nvSpPr>
+          <p:cNvPr id="17" name="Text 15"/>
+          <p:cNvSpPr/>
+          <p:nvPr/>
+        </p:nvSpPr>
+        <p:spPr>
+          <a:xfrm>
+            <a:off x="8485632" y="2743200"/>
+            <a:ext cx="2926080" cy="365760"/>
+          </a:xfrm>
+          <a:prstGeom prst="rect">
+            <a:avLst/>
+          </a:prstGeom>
+          <a:noFill/>
+          <a:ln/>
+        </p:spPr>
+        <p:txBody>
+          <a:bodyPr wrap="square" lIns="0" tIns="0" rIns="0" bIns="0" rtlCol="0" anchor="ctr"/>
+          <a:lstStyle/>
+          <a:p>
+            <a:pPr indent="0" marL="0">
+              <a:buNone/>
+            </a:pPr>
+            <a:r>
+              <a:rPr lang="en-US" sz="1700" b="1" dirty="0">
+                <a:solidFill>
+                  <a:srgbClr val="1D4ED8"/>
+                </a:solidFill>
+                <a:latin typeface="Georgia" pitchFamily="34" charset="0"/>
+                <a:ea typeface="Georgia" pitchFamily="34" charset="-122"/>
+                <a:cs typeface="Georgia" pitchFamily="34" charset="-120"/>
+              </a:rPr>
+              <a:t>3 · Draft</a:t>
+            </a:r>
+            <a:endParaRPr lang="en-US" sz="1700" dirty="0"/>
+          </a:p>
+        </p:txBody>
+      </p:sp>
+      <p:sp>
+        <p:nvSpPr>
+          <p:cNvPr id="18" name="Text 16"/>
+          <p:cNvSpPr/>
+          <p:nvPr/>
+        </p:nvSpPr>
+        <p:spPr>
+          <a:xfrm>
+            <a:off x="8485632" y="3200400"/>
+            <a:ext cx="2971800" cy="960120"/>
+          </a:xfrm>
+          <a:prstGeom prst="rect">
+            <a:avLst/>
+          </a:prstGeom>
+          <a:noFill/>
+          <a:ln/>
+        </p:spPr>
+        <p:txBody>
+          <a:bodyPr wrap="square" lIns="0" tIns="0" rIns="0" bIns="0" rtlCol="0" anchor="ctr"/>
+          <a:lstStyle/>
+          <a:p>
+            <a:pPr indent="0" marL="0">
+              <a:buNone/>
+            </a:pPr>
+            <a:r>
+              <a:rPr lang="en-US" sz="1250" dirty="0">
+                <a:solidFill>
+                  <a:srgbClr val="64748B"/>
+                </a:solidFill>
+                <a:latin typeface="Calibri" pitchFamily="34" charset="0"/>
+                <a:ea typeface="Calibri" pitchFamily="34" charset="-122"/>
+                <a:cs typeface="Calibri" pitchFamily="34" charset="-120"/>
+              </a:rPr>
+              <a:t>It writes every section in your brand voice, ending with an e-sign call to action.</a:t>
+            </a:r>
+            <a:endParaRPr lang="en-US" sz="1250" dirty="0"/>
+          </a:p>
+        </p:txBody>
+      </p:sp>
+      <p:sp>
+        <p:nvSpPr>
+          <p:cNvPr id="19" name="Text 17"/>
+          <p:cNvSpPr/>
+          <p:nvPr/>
+        </p:nvSpPr>
+        <p:spPr>
+          <a:xfrm>
+            <a:off x="822960" y="4617720"/>
+            <a:ext cx="5303520" cy="411480"/>
+          </a:xfrm>
+          <a:prstGeom prst="rect">
+            <a:avLst/>
+          </a:prstGeom>
+          <a:noFill/>
+          <a:ln/>
+        </p:spPr>
+        <p:txBody>
+          <a:bodyPr wrap="square" lIns="0" tIns="0" rIns="0" bIns="0" rtlCol="0" anchor="ctr"/>
+          <a:lstStyle/>
+          <a:p>
+            <a:pPr indent="0" marL="0">
+              <a:buNone/>
+            </a:pPr>
+            <a:r>
+              <a:rPr lang="en-US" sz="1350" b="1" dirty="0">
+                <a:solidFill>
+                  <a:srgbClr val="16A34A"/>
+                </a:solidFill>
+                <a:latin typeface="Calibri" pitchFamily="34" charset="0"/>
+                <a:ea typeface="Calibri" pitchFamily="34" charset="-122"/>
+                <a:cs typeface="Calibri" pitchFamily="34" charset="-120"/>
+              </a:rPr>
+              <a:t>✓  </a:t>
+            </a:r>
+            <a:pPr indent="0" marL="0">
+              <a:buNone/>
+            </a:pPr>
+            <a:r>
+              <a:rPr lang="en-US" sz="1350" dirty="0">
+                <a:solidFill>
+                  <a:srgbClr val="1E293B"/>
+                </a:solidFill>
+                <a:latin typeface="Calibri" pitchFamily="34" charset="0"/>
+                <a:ea typeface="Calibri" pitchFamily="34" charset="-122"/>
+                <a:cs typeface="Calibri" pitchFamily="34" charset="-120"/>
+              </a:rPr>
+              <a:t>Writes as your business — your Proposal Voice</a:t>
+            </a:r>
+            <a:endParaRPr lang="en-US" sz="1350" dirty="0"/>
+          </a:p>
+        </p:txBody>
+      </p:sp>
+      <p:sp>
+        <p:nvSpPr>
+          <p:cNvPr id="20" name="Text 18"/>
+          <p:cNvSpPr/>
+          <p:nvPr/>
+        </p:nvSpPr>
+        <p:spPr>
+          <a:xfrm>
+            <a:off x="6263640" y="4617720"/>
+            <a:ext cx="5303520" cy="411480"/>
+          </a:xfrm>
+          <a:prstGeom prst="rect">
+            <a:avLst/>
+          </a:prstGeom>
+          <a:noFill/>
+          <a:ln/>
+        </p:spPr>
+        <p:txBody>
+          <a:bodyPr wrap="square" lIns="0" tIns="0" rIns="0" bIns="0" rtlCol="0" anchor="ctr"/>
+          <a:lstStyle/>
+          <a:p>
+            <a:pPr indent="0" marL="0">
+              <a:buNone/>
+            </a:pPr>
+            <a:r>
+              <a:rPr lang="en-US" sz="1350" b="1" dirty="0">
+                <a:solidFill>
+                  <a:srgbClr val="16A34A"/>
+                </a:solidFill>
+                <a:latin typeface="Calibri" pitchFamily="34" charset="0"/>
+                <a:ea typeface="Calibri" pitchFamily="34" charset="-122"/>
+                <a:cs typeface="Calibri" pitchFamily="34" charset="-120"/>
+              </a:rPr>
+              <a:t>✓  </a:t>
+            </a:r>
+            <a:pPr indent="0" marL="0">
+              <a:buNone/>
+            </a:pPr>
+            <a:r>
+              <a:rPr lang="en-US" sz="1350" dirty="0">
+                <a:solidFill>
+                  <a:srgbClr val="1E293B"/>
+                </a:solidFill>
+                <a:latin typeface="Calibri" pitchFamily="34" charset="0"/>
+                <a:ea typeface="Calibri" pitchFamily="34" charset="-122"/>
+                <a:cs typeface="Calibri" pitchFamily="34" charset="-120"/>
+              </a:rPr>
+              <a:t>Uses your private Client Notes to target pain points</a:t>
+            </a:r>
+            <a:endParaRPr lang="en-US" sz="1350" dirty="0"/>
+          </a:p>
+        </p:txBody>
+      </p:sp>
+      <p:sp>
+        <p:nvSpPr>
+          <p:cNvPr id="21" name="Text 19"/>
+          <p:cNvSpPr/>
+          <p:nvPr/>
+        </p:nvSpPr>
+        <p:spPr>
+          <a:xfrm>
+            <a:off x="822960" y="5093208"/>
+            <a:ext cx="5303520" cy="411480"/>
+          </a:xfrm>
+          <a:prstGeom prst="rect">
+            <a:avLst/>
+          </a:prstGeom>
+          <a:noFill/>
+          <a:ln/>
+        </p:spPr>
+        <p:txBody>
+          <a:bodyPr wrap="square" lIns="0" tIns="0" rIns="0" bIns="0" rtlCol="0" anchor="ctr"/>
+          <a:lstStyle/>
+          <a:p>
+            <a:pPr indent="0" marL="0">
+              <a:buNone/>
+            </a:pPr>
+            <a:r>
+              <a:rPr lang="en-US" sz="1350" b="1" dirty="0">
+                <a:solidFill>
+                  <a:srgbClr val="16A34A"/>
+                </a:solidFill>
+                <a:latin typeface="Calibri" pitchFamily="34" charset="0"/>
+                <a:ea typeface="Calibri" pitchFamily="34" charset="-122"/>
+                <a:cs typeface="Calibri" pitchFamily="34" charset="-120"/>
+              </a:rPr>
+              <a:t>✓  </a:t>
+            </a:r>
+            <a:pPr indent="0" marL="0">
+              <a:buNone/>
+            </a:pPr>
+            <a:r>
+              <a:rPr lang="en-US" sz="1350" dirty="0">
+                <a:solidFill>
+                  <a:srgbClr val="1E293B"/>
+                </a:solidFill>
+                <a:latin typeface="Calibri" pitchFamily="34" charset="0"/>
+                <a:ea typeface="Calibri" pitchFamily="34" charset="-122"/>
+                <a:cs typeface="Calibri" pitchFamily="34" charset="-120"/>
+              </a:rPr>
+              <a:t>Reads pricing scenarios directly — no re-keying</a:t>
+            </a:r>
+            <a:endParaRPr lang="en-US" sz="1350" dirty="0"/>
+          </a:p>
+        </p:txBody>
+      </p:sp>
+      <p:sp>
+        <p:nvSpPr>
+          <p:cNvPr id="22" name="Text 20"/>
+          <p:cNvSpPr/>
+          <p:nvPr/>
+        </p:nvSpPr>
+        <p:spPr>
+          <a:xfrm>
+            <a:off x="6263640" y="5093208"/>
+            <a:ext cx="5303520" cy="411480"/>
+          </a:xfrm>
+          <a:prstGeom prst="rect">
+            <a:avLst/>
+          </a:prstGeom>
+          <a:noFill/>
+          <a:ln/>
+        </p:spPr>
+        <p:txBody>
+          <a:bodyPr wrap="square" lIns="0" tIns="0" rIns="0" bIns="0" rtlCol="0" anchor="ctr"/>
+          <a:lstStyle/>
+          <a:p>
+            <a:pPr indent="0" marL="0">
+              <a:buNone/>
+            </a:pPr>
+            <a:r>
+              <a:rPr lang="en-US" sz="1350" b="1" dirty="0">
+                <a:solidFill>
+                  <a:srgbClr val="16A34A"/>
+                </a:solidFill>
+                <a:latin typeface="Calibri" pitchFamily="34" charset="0"/>
+                <a:ea typeface="Calibri" pitchFamily="34" charset="-122"/>
+                <a:cs typeface="Calibri" pitchFamily="34" charset="-120"/>
+              </a:rPr>
+              <a:t>✓  </a:t>
+            </a:r>
+            <a:pPr indent="0" marL="0">
+              <a:buNone/>
+            </a:pPr>
+            <a:r>
+              <a:rPr lang="en-US" sz="1350" dirty="0">
+                <a:solidFill>
+                  <a:srgbClr val="1E293B"/>
+                </a:solidFill>
+                <a:latin typeface="Calibri" pitchFamily="34" charset="0"/>
+                <a:ea typeface="Calibri" pitchFamily="34" charset="-122"/>
+                <a:cs typeface="Calibri" pitchFamily="34" charset="-120"/>
+              </a:rPr>
+              <a:t>Preview &amp; edit before anything is inserted</a:t>
+            </a:r>
+            <a:endParaRPr lang="en-US" sz="1350" dirty="0"/>
+          </a:p>
+        </p:txBody>
+      </p:sp>
+      <p:sp>
+        <p:nvSpPr>
+          <p:cNvPr id="23" name="Text 21"/>
+          <p:cNvSpPr/>
+          <p:nvPr/>
+        </p:nvSpPr>
+        <p:spPr>
+          <a:xfrm>
+            <a:off x="822960" y="5715000"/>
+            <a:ext cx="10424160" cy="365760"/>
+          </a:xfrm>
+          <a:prstGeom prst="rect">
+            <a:avLst/>
+          </a:prstGeom>
+          <a:noFill/>
+          <a:ln/>
+        </p:spPr>
+        <p:txBody>
+          <a:bodyPr wrap="square" lIns="0" tIns="0" rIns="0" bIns="0" rtlCol="0" anchor="ctr"/>
+          <a:lstStyle/>
+          <a:p>
+            <a:pPr indent="0" marL="0">
+              <a:buNone/>
+            </a:pPr>
+            <a:r>
+              <a:rPr lang="en-US" sz="1300" i="1" dirty="0">
+                <a:solidFill>
+                  <a:srgbClr val="1D4ED8"/>
+                </a:solidFill>
+                <a:latin typeface="Calibri" pitchFamily="34" charset="0"/>
+                <a:ea typeface="Calibri" pitchFamily="34" charset="-122"/>
+                <a:cs typeface="Calibri" pitchFamily="34" charset="-120"/>
+              </a:rPr>
+              <a:t>Plus inline “Ask AI” to improve, expand, shorten, or re-tone any selection.</a:t>
+            </a:r>
+            <a:endParaRPr lang="en-US" sz="1300" dirty="0"/>
+          </a:p>
+        </p:txBody>
+      </p:sp>
+    </p:spTree>
+  </p:cSld>
+  <p:clrMapOvr>
+    <a:masterClrMapping/>
+  </p:clrMapOvr>
+</p:sld>
+</file>
+
+<file path=ppt/slides/slide6.xml><?xml version="1.0" encoding="utf-8"?>
+<p:sld xmlns:a="http://schemas.openxmlformats.org/drawingml/2006/main" xmlns:r="http://schemas.openxmlformats.org/officeDocument/2006/relationships" xmlns:p="http://schemas.openxmlformats.org/presentationml/2006/main">
+  <p:cSld name="Slide 6">
+    <p:bg>
+      <p:bgPr>
+        <a:solidFill>
           <a:srgbClr val="0B1F3A"/>
         </a:solidFill>
       </p:bgPr>
@@ -5114,9 +6071,9 @@
 </p:sld>
 </file>
 
-<file path=ppt/slides/slide6.xml><?xml version="1.0" encoding="utf-8"?>
+<file path=ppt/slides/slide7.xml><?xml version="1.0" encoding="utf-8"?>
 <p:sld xmlns:a="http://schemas.openxmlformats.org/drawingml/2006/main" xmlns:r="http://schemas.openxmlformats.org/officeDocument/2006/relationships" xmlns:p="http://schemas.openxmlformats.org/presentationml/2006/main">
-  <p:cSld name="Slide 6">
+  <p:cSld name="Slide 7">
     <p:bg>
       <p:bgPr>
         <a:solidFill>
@@ -6477,9 +7434,9 @@
 </p:sld>
 </file>
 
-<file path=ppt/slides/slide7.xml><?xml version="1.0" encoding="utf-8"?>
+<file path=ppt/slides/slide8.xml><?xml version="1.0" encoding="utf-8"?>
 <p:sld xmlns:a="http://schemas.openxmlformats.org/drawingml/2006/main" xmlns:r="http://schemas.openxmlformats.org/officeDocument/2006/relationships" xmlns:p="http://schemas.openxmlformats.org/presentationml/2006/main">
-  <p:cSld name="Slide 7">
+  <p:cSld name="Slide 8">
     <p:bg>
       <p:bgPr>
         <a:solidFill>

</xml_diff>

<commit_message>
Deck: add a dedicated AI Draft spotlight slide (#17)
The pitch deck only mentioned AI Draft as one tile among nine features. Add a
dedicated spotlight slide (now slide 5 of 8) showing the flagship's depth:
Intake -> Outline -> Draft flow, grounded in the quote (never invents numbers),
writes in your Proposal Voice, uses private Client Notes, ends with an e-sign CTA,
preview-before-insert, plus inline Ask AI. Regenerated ultraquote-deck.pptx.

Co-authored-by: Sameer Pandya <sameer@ultraedge.us>
Co-authored-by: Claude Opus 4.8 <noreply@anthropic.com>
</commit_message>
<xml_diff>
--- a/marketing-materials/ultraquote-deck.pptx
+++ b/marketing-materials/ultraquote-deck.pptx
@@ -12,9 +12,10 @@
     <p:sldId id="260" r:id="rId6"/>
     <p:sldId id="261" r:id="rId7"/>
     <p:sldId id="262" r:id="rId8"/>
+    <p:sldId id="263" r:id="rId9"/>
   </p:sldIdLst>
   <p:notesMasterIdLst>
-    <p:notesMasterId r:id="rId9"/>
+    <p:notesMasterId r:id="rId10"/>
   </p:notesMasterIdLst>
   <p:sldSz cx="12192000" cy="6858000"/>
   <p:notesSz cx="6858000" cy="12192000"/>
@@ -1060,6 +1061,94 @@
             <a:fld id="{F7021451-1387-4CA6-816F-3879F97B5CBC}" type="slidenum">
               <a:rPr lang="en-US"/>
               <a:t>7</a:t>
+            </a:fld>
+            <a:endParaRPr lang="en-US"/>
+          </a:p>
+        </p:txBody>
+      </p:sp>
+    </p:spTree>
+    <p:extLst>
+      <p:ext uri="{BB962C8B-B14F-4D97-AF65-F5344CB8AC3E}">
+        <p14:creationId xmlns:p14="http://schemas.microsoft.com/office/powerpoint/2010/main" val="1024086991"/>
+      </p:ext>
+    </p:extLst>
+  </p:cSld>
+  <p:clrMapOvr>
+    <a:masterClrMapping/>
+  </p:clrMapOvr>
+</p:notes>
+</file>
+
+<file path=ppt/notesSlides/notesSlide8.xml><?xml version="1.0" encoding="utf-8"?>
+<p:notes xmlns:a="http://schemas.openxmlformats.org/drawingml/2006/main" xmlns:r="http://schemas.openxmlformats.org/officeDocument/2006/relationships" xmlns:p="http://schemas.openxmlformats.org/presentationml/2006/main">
+  <p:cSld>
+    <p:spTree>
+      <p:nvGrpSpPr>
+        <p:cNvPr id="1" name=""/>
+        <p:cNvGrpSpPr/>
+        <p:nvPr/>
+      </p:nvGrpSpPr>
+      <p:grpSpPr>
+        <a:xfrm>
+          <a:off x="0" y="0"/>
+          <a:ext cx="0" cy="0"/>
+          <a:chOff x="0" y="0"/>
+          <a:chExt cx="0" cy="0"/>
+        </a:xfrm>
+      </p:grpSpPr>
+      <p:sp>
+        <p:nvSpPr>
+          <p:cNvPr id="2" name="Slide Image Placeholder 1"/>
+          <p:cNvSpPr>
+            <a:spLocks noGrp="1" noRot="1" noChangeAspect="1"/>
+          </p:cNvSpPr>
+          <p:nvPr>
+            <p:ph type="sldImg"/>
+          </p:nvPr>
+        </p:nvSpPr>
+        <p:spPr/>
+      </p:sp>
+      <p:sp>
+        <p:nvSpPr>
+          <p:cNvPr id="3" name="Notes Placeholder 2"/>
+          <p:cNvSpPr>
+            <a:spLocks noGrp="1"/>
+          </p:cNvSpPr>
+          <p:nvPr>
+            <p:ph type="body" idx="1"/>
+          </p:nvPr>
+        </p:nvSpPr>
+        <p:spPr/>
+        <p:txBody>
+          <a:bodyPr/>
+          <a:lstStyle/>
+          <a:p>
+            <a:r>
+              <a:rPr lang="en-US" dirty="0"/>
+              <a:t/>
+            </a:r>
+            <a:endParaRPr lang="en-US" dirty="0"/>
+          </a:p>
+        </p:txBody>
+      </p:sp>
+      <p:sp>
+        <p:nvSpPr>
+          <p:cNvPr id="4" name="Slide Number Placeholder 3"/>
+          <p:cNvSpPr>
+            <a:spLocks noGrp="1"/>
+          </p:cNvSpPr>
+          <p:nvPr>
+            <p:ph type="sldNum" sz="quarter" idx="10"/>
+          </p:nvPr>
+        </p:nvSpPr>
+        <p:spPr/>
+        <p:txBody>
+          <a:bodyPr/>
+          <a:lstStyle/>
+          <a:p>
+            <a:fld id="{F7021451-1387-4CA6-816F-3879F97B5CBC}" type="slidenum">
+              <a:rPr lang="en-US"/>
+              <a:t>8</a:t>
             </a:fld>
             <a:endParaRPr lang="en-US"/>
           </a:p>
@@ -4442,6 +4531,874 @@
     <p:bg>
       <p:bgPr>
         <a:solidFill>
+          <a:srgbClr val="EFF6FF"/>
+        </a:solidFill>
+      </p:bgPr>
+    </p:bg>
+    <p:spTree>
+      <p:nvGrpSpPr>
+        <p:cNvPr id="1" name=""/>
+        <p:cNvGrpSpPr/>
+        <p:nvPr/>
+      </p:nvGrpSpPr>
+      <p:grpSpPr>
+        <a:xfrm>
+          <a:off x="0" y="0"/>
+          <a:ext cx="0" cy="0"/>
+          <a:chOff x="0" y="0"/>
+          <a:chExt cx="0" cy="0"/>
+        </a:xfrm>
+      </p:grpSpPr>
+      <p:sp>
+        <p:nvSpPr>
+          <p:cNvPr id="2" name="Text 0"/>
+          <p:cNvSpPr/>
+          <p:nvPr/>
+        </p:nvSpPr>
+        <p:spPr>
+          <a:xfrm>
+            <a:off x="822960" y="502920"/>
+            <a:ext cx="7315200" cy="274320"/>
+          </a:xfrm>
+          <a:prstGeom prst="rect">
+            <a:avLst/>
+          </a:prstGeom>
+          <a:noFill/>
+          <a:ln/>
+        </p:spPr>
+        <p:txBody>
+          <a:bodyPr wrap="square" lIns="0" tIns="0" rIns="0" bIns="0" rtlCol="0" anchor="ctr"/>
+          <a:lstStyle/>
+          <a:p>
+            <a:pPr indent="0" marL="0">
+              <a:buNone/>
+            </a:pPr>
+            <a:r>
+              <a:rPr lang="en-US" sz="1200" b="1" spc="200" kern="0" dirty="0">
+                <a:solidFill>
+                  <a:srgbClr val="0F5F5C"/>
+                </a:solidFill>
+                <a:latin typeface="Calibri" pitchFamily="34" charset="0"/>
+                <a:ea typeface="Calibri" pitchFamily="34" charset="-122"/>
+                <a:cs typeface="Calibri" pitchFamily="34" charset="-120"/>
+              </a:rPr>
+              <a:t>FEATURED · AI PROPOSAL DRAFTING</a:t>
+            </a:r>
+            <a:endParaRPr lang="en-US" sz="1200" dirty="0"/>
+          </a:p>
+        </p:txBody>
+      </p:sp>
+      <p:sp>
+        <p:nvSpPr>
+          <p:cNvPr id="3" name="Text 1"/>
+          <p:cNvSpPr/>
+          <p:nvPr/>
+        </p:nvSpPr>
+        <p:spPr>
+          <a:xfrm>
+            <a:off x="822960" y="822960"/>
+            <a:ext cx="10515600" cy="731520"/>
+          </a:xfrm>
+          <a:prstGeom prst="rect">
+            <a:avLst/>
+          </a:prstGeom>
+          <a:noFill/>
+          <a:ln/>
+        </p:spPr>
+        <p:txBody>
+          <a:bodyPr wrap="square" lIns="0" tIns="0" rIns="0" bIns="0" rtlCol="0" anchor="ctr"/>
+          <a:lstStyle/>
+          <a:p>
+            <a:pPr indent="0" marL="0">
+              <a:buNone/>
+            </a:pPr>
+            <a:r>
+              <a:rPr lang="en-US" sz="3000" b="1" dirty="0">
+                <a:solidFill>
+                  <a:srgbClr val="0B1F3A"/>
+                </a:solidFill>
+                <a:latin typeface="Georgia" pitchFamily="34" charset="0"/>
+                <a:ea typeface="Georgia" pitchFamily="34" charset="-122"/>
+                <a:cs typeface="Georgia" pitchFamily="34" charset="-120"/>
+              </a:rPr>
+              <a:t>Let AI draft the whole proposal — in your voice.</a:t>
+            </a:r>
+            <a:endParaRPr lang="en-US" sz="3000" dirty="0"/>
+          </a:p>
+        </p:txBody>
+      </p:sp>
+      <p:sp>
+        <p:nvSpPr>
+          <p:cNvPr id="4" name="Text 2"/>
+          <p:cNvSpPr/>
+          <p:nvPr/>
+        </p:nvSpPr>
+        <p:spPr>
+          <a:xfrm>
+            <a:off x="822960" y="1572768"/>
+            <a:ext cx="10424160" cy="548640"/>
+          </a:xfrm>
+          <a:prstGeom prst="rect">
+            <a:avLst/>
+          </a:prstGeom>
+          <a:noFill/>
+          <a:ln/>
+        </p:spPr>
+        <p:txBody>
+          <a:bodyPr wrap="square" lIns="0" tIns="0" rIns="0" bIns="0" rtlCol="0" anchor="ctr"/>
+          <a:lstStyle/>
+          <a:p>
+            <a:pPr indent="0" marL="0">
+              <a:buNone/>
+            </a:pPr>
+            <a:r>
+              <a:rPr lang="en-US" sz="1500" dirty="0">
+                <a:solidFill>
+                  <a:srgbClr val="64748B"/>
+                </a:solidFill>
+                <a:latin typeface="Calibri" pitchFamily="34" charset="0"/>
+                <a:ea typeface="Calibri" pitchFamily="34" charset="-122"/>
+                <a:cs typeface="Calibri" pitchFamily="34" charset="-120"/>
+              </a:rPr>
+              <a:t>Grounded in your quote's own services, pricing, and client — the AI never invents numbers, and you review every word before it's inserted.</a:t>
+            </a:r>
+            <a:endParaRPr lang="en-US" sz="1500" dirty="0"/>
+          </a:p>
+        </p:txBody>
+      </p:sp>
+      <p:sp>
+        <p:nvSpPr>
+          <p:cNvPr id="5" name="Shape 3"/>
+          <p:cNvSpPr/>
+          <p:nvPr/>
+        </p:nvSpPr>
+        <p:spPr>
+          <a:xfrm>
+            <a:off x="822960" y="2514600"/>
+            <a:ext cx="3383280" cy="1737360"/>
+          </a:xfrm>
+          <a:prstGeom prst="rect">
+            <a:avLst/>
+          </a:prstGeom>
+          <a:solidFill>
+            <a:srgbClr val="FFFFFF"/>
+          </a:solidFill>
+          <a:ln w="12700">
+            <a:solidFill>
+              <a:srgbClr val="E2E8F0"/>
+            </a:solidFill>
+            <a:prstDash val="solid"/>
+          </a:ln>
+          <a:effectLst>
+            <a:outerShdw sx="100000" sy="100000" kx="0" ky="0" algn="bl" rotWithShape="0" blurRad="114300" dist="38100" dir="8100000">
+              <a:srgbClr val="0F172A">
+                <a:alpha val="12000"/>
+              </a:srgbClr>
+            </a:outerShdw>
+          </a:effectLst>
+        </p:spPr>
+      </p:sp>
+      <p:sp>
+        <p:nvSpPr>
+          <p:cNvPr id="6" name="Shape 4"/>
+          <p:cNvSpPr/>
+          <p:nvPr/>
+        </p:nvSpPr>
+        <p:spPr>
+          <a:xfrm>
+            <a:off x="822960" y="2514600"/>
+            <a:ext cx="3383280" cy="82296"/>
+          </a:xfrm>
+          <a:prstGeom prst="rect">
+            <a:avLst/>
+          </a:prstGeom>
+          <a:solidFill>
+            <a:srgbClr val="0EA5A4"/>
+          </a:solidFill>
+          <a:ln/>
+        </p:spPr>
+      </p:sp>
+      <p:sp>
+        <p:nvSpPr>
+          <p:cNvPr id="7" name="Text 5"/>
+          <p:cNvSpPr/>
+          <p:nvPr/>
+        </p:nvSpPr>
+        <p:spPr>
+          <a:xfrm>
+            <a:off x="1078992" y="2743200"/>
+            <a:ext cx="2926080" cy="365760"/>
+          </a:xfrm>
+          <a:prstGeom prst="rect">
+            <a:avLst/>
+          </a:prstGeom>
+          <a:noFill/>
+          <a:ln/>
+        </p:spPr>
+        <p:txBody>
+          <a:bodyPr wrap="square" lIns="0" tIns="0" rIns="0" bIns="0" rtlCol="0" anchor="ctr"/>
+          <a:lstStyle/>
+          <a:p>
+            <a:pPr indent="0" marL="0">
+              <a:buNone/>
+            </a:pPr>
+            <a:r>
+              <a:rPr lang="en-US" sz="1700" b="1" dirty="0">
+                <a:solidFill>
+                  <a:srgbClr val="1D4ED8"/>
+                </a:solidFill>
+                <a:latin typeface="Georgia" pitchFamily="34" charset="0"/>
+                <a:ea typeface="Georgia" pitchFamily="34" charset="-122"/>
+                <a:cs typeface="Georgia" pitchFamily="34" charset="-120"/>
+              </a:rPr>
+              <a:t>1 · Intake</a:t>
+            </a:r>
+            <a:endParaRPr lang="en-US" sz="1700" dirty="0"/>
+          </a:p>
+        </p:txBody>
+      </p:sp>
+      <p:sp>
+        <p:nvSpPr>
+          <p:cNvPr id="8" name="Text 6"/>
+          <p:cNvSpPr/>
+          <p:nvPr/>
+        </p:nvSpPr>
+        <p:spPr>
+          <a:xfrm>
+            <a:off x="1078992" y="3200400"/>
+            <a:ext cx="2971800" cy="960120"/>
+          </a:xfrm>
+          <a:prstGeom prst="rect">
+            <a:avLst/>
+          </a:prstGeom>
+          <a:noFill/>
+          <a:ln/>
+        </p:spPr>
+        <p:txBody>
+          <a:bodyPr wrap="square" lIns="0" tIns="0" rIns="0" bIns="0" rtlCol="0" anchor="ctr"/>
+          <a:lstStyle/>
+          <a:p>
+            <a:pPr indent="0" marL="0">
+              <a:buNone/>
+            </a:pPr>
+            <a:r>
+              <a:rPr lang="en-US" sz="1250" dirty="0">
+                <a:solidFill>
+                  <a:srgbClr val="64748B"/>
+                </a:solidFill>
+                <a:latin typeface="Calibri" pitchFamily="34" charset="0"/>
+                <a:ea typeface="Calibri" pitchFamily="34" charset="-122"/>
+                <a:cs typeface="Calibri" pitchFamily="34" charset="-120"/>
+              </a:rPr>
+              <a:t>Set the style — tone, length, emphasis. Optionally reference a past proposal to match.</a:t>
+            </a:r>
+            <a:endParaRPr lang="en-US" sz="1250" dirty="0"/>
+          </a:p>
+        </p:txBody>
+      </p:sp>
+      <p:sp>
+        <p:nvSpPr>
+          <p:cNvPr id="9" name="Text 7"/>
+          <p:cNvSpPr/>
+          <p:nvPr/>
+        </p:nvSpPr>
+        <p:spPr>
+          <a:xfrm>
+            <a:off x="4206240" y="3154680"/>
+            <a:ext cx="384048" cy="457200"/>
+          </a:xfrm>
+          <a:prstGeom prst="rect">
+            <a:avLst/>
+          </a:prstGeom>
+          <a:noFill/>
+          <a:ln/>
+        </p:spPr>
+        <p:txBody>
+          <a:bodyPr wrap="square" lIns="0" tIns="0" rIns="0" bIns="0" rtlCol="0" anchor="ctr"/>
+          <a:lstStyle/>
+          <a:p>
+            <a:pPr algn="ctr" indent="0" marL="0">
+              <a:buNone/>
+            </a:pPr>
+            <a:r>
+              <a:rPr lang="en-US" sz="2200" b="1" dirty="0">
+                <a:solidFill>
+                  <a:srgbClr val="0EA5A4"/>
+                </a:solidFill>
+                <a:latin typeface="Calibri" pitchFamily="34" charset="0"/>
+                <a:ea typeface="Calibri" pitchFamily="34" charset="-122"/>
+                <a:cs typeface="Calibri" pitchFamily="34" charset="-120"/>
+              </a:rPr>
+              <a:t>→</a:t>
+            </a:r>
+            <a:endParaRPr lang="en-US" sz="2200" dirty="0"/>
+          </a:p>
+        </p:txBody>
+      </p:sp>
+      <p:sp>
+        <p:nvSpPr>
+          <p:cNvPr id="10" name="Shape 8"/>
+          <p:cNvSpPr/>
+          <p:nvPr/>
+        </p:nvSpPr>
+        <p:spPr>
+          <a:xfrm>
+            <a:off x="4526280" y="2514600"/>
+            <a:ext cx="3383280" cy="1737360"/>
+          </a:xfrm>
+          <a:prstGeom prst="rect">
+            <a:avLst/>
+          </a:prstGeom>
+          <a:solidFill>
+            <a:srgbClr val="FFFFFF"/>
+          </a:solidFill>
+          <a:ln w="12700">
+            <a:solidFill>
+              <a:srgbClr val="E2E8F0"/>
+            </a:solidFill>
+            <a:prstDash val="solid"/>
+          </a:ln>
+          <a:effectLst>
+            <a:outerShdw sx="100000" sy="100000" kx="0" ky="0" algn="bl" rotWithShape="0" blurRad="114300" dist="38100" dir="8100000">
+              <a:srgbClr val="0F172A">
+                <a:alpha val="12000"/>
+              </a:srgbClr>
+            </a:outerShdw>
+          </a:effectLst>
+        </p:spPr>
+      </p:sp>
+      <p:sp>
+        <p:nvSpPr>
+          <p:cNvPr id="11" name="Shape 9"/>
+          <p:cNvSpPr/>
+          <p:nvPr/>
+        </p:nvSpPr>
+        <p:spPr>
+          <a:xfrm>
+            <a:off x="4526280" y="2514600"/>
+            <a:ext cx="3383280" cy="82296"/>
+          </a:xfrm>
+          <a:prstGeom prst="rect">
+            <a:avLst/>
+          </a:prstGeom>
+          <a:solidFill>
+            <a:srgbClr val="0EA5A4"/>
+          </a:solidFill>
+          <a:ln/>
+        </p:spPr>
+      </p:sp>
+      <p:sp>
+        <p:nvSpPr>
+          <p:cNvPr id="12" name="Text 10"/>
+          <p:cNvSpPr/>
+          <p:nvPr/>
+        </p:nvSpPr>
+        <p:spPr>
+          <a:xfrm>
+            <a:off x="4782312" y="2743200"/>
+            <a:ext cx="2926080" cy="365760"/>
+          </a:xfrm>
+          <a:prstGeom prst="rect">
+            <a:avLst/>
+          </a:prstGeom>
+          <a:noFill/>
+          <a:ln/>
+        </p:spPr>
+        <p:txBody>
+          <a:bodyPr wrap="square" lIns="0" tIns="0" rIns="0" bIns="0" rtlCol="0" anchor="ctr"/>
+          <a:lstStyle/>
+          <a:p>
+            <a:pPr indent="0" marL="0">
+              <a:buNone/>
+            </a:pPr>
+            <a:r>
+              <a:rPr lang="en-US" sz="1700" b="1" dirty="0">
+                <a:solidFill>
+                  <a:srgbClr val="1D4ED8"/>
+                </a:solidFill>
+                <a:latin typeface="Georgia" pitchFamily="34" charset="0"/>
+                <a:ea typeface="Georgia" pitchFamily="34" charset="-122"/>
+                <a:cs typeface="Georgia" pitchFamily="34" charset="-120"/>
+              </a:rPr>
+              <a:t>2 · Outline</a:t>
+            </a:r>
+            <a:endParaRPr lang="en-US" sz="1700" dirty="0"/>
+          </a:p>
+        </p:txBody>
+      </p:sp>
+      <p:sp>
+        <p:nvSpPr>
+          <p:cNvPr id="13" name="Text 11"/>
+          <p:cNvSpPr/>
+          <p:nvPr/>
+        </p:nvSpPr>
+        <p:spPr>
+          <a:xfrm>
+            <a:off x="4782312" y="3200400"/>
+            <a:ext cx="2971800" cy="960120"/>
+          </a:xfrm>
+          <a:prstGeom prst="rect">
+            <a:avLst/>
+          </a:prstGeom>
+          <a:noFill/>
+          <a:ln/>
+        </p:spPr>
+        <p:txBody>
+          <a:bodyPr wrap="square" lIns="0" tIns="0" rIns="0" bIns="0" rtlCol="0" anchor="ctr"/>
+          <a:lstStyle/>
+          <a:p>
+            <a:pPr indent="0" marL="0">
+              <a:buNone/>
+            </a:pPr>
+            <a:r>
+              <a:rPr lang="en-US" sz="1250" dirty="0">
+                <a:solidFill>
+                  <a:srgbClr val="64748B"/>
+                </a:solidFill>
+                <a:latin typeface="Calibri" pitchFamily="34" charset="0"/>
+                <a:ea typeface="Calibri" pitchFamily="34" charset="-122"/>
+                <a:cs typeface="Calibri" pitchFamily="34" charset="-120"/>
+              </a:rPr>
+              <a:t>AI proposes a section outline tailored to the deal. Rename, reorder, add, or remove.</a:t>
+            </a:r>
+            <a:endParaRPr lang="en-US" sz="1250" dirty="0"/>
+          </a:p>
+        </p:txBody>
+      </p:sp>
+      <p:sp>
+        <p:nvSpPr>
+          <p:cNvPr id="14" name="Text 12"/>
+          <p:cNvSpPr/>
+          <p:nvPr/>
+        </p:nvSpPr>
+        <p:spPr>
+          <a:xfrm>
+            <a:off x="7909560" y="3154680"/>
+            <a:ext cx="384048" cy="457200"/>
+          </a:xfrm>
+          <a:prstGeom prst="rect">
+            <a:avLst/>
+          </a:prstGeom>
+          <a:noFill/>
+          <a:ln/>
+        </p:spPr>
+        <p:txBody>
+          <a:bodyPr wrap="square" lIns="0" tIns="0" rIns="0" bIns="0" rtlCol="0" anchor="ctr"/>
+          <a:lstStyle/>
+          <a:p>
+            <a:pPr algn="ctr" indent="0" marL="0">
+              <a:buNone/>
+            </a:pPr>
+            <a:r>
+              <a:rPr lang="en-US" sz="2200" b="1" dirty="0">
+                <a:solidFill>
+                  <a:srgbClr val="0EA5A4"/>
+                </a:solidFill>
+                <a:latin typeface="Calibri" pitchFamily="34" charset="0"/>
+                <a:ea typeface="Calibri" pitchFamily="34" charset="-122"/>
+                <a:cs typeface="Calibri" pitchFamily="34" charset="-120"/>
+              </a:rPr>
+              <a:t>→</a:t>
+            </a:r>
+            <a:endParaRPr lang="en-US" sz="2200" dirty="0"/>
+          </a:p>
+        </p:txBody>
+      </p:sp>
+      <p:sp>
+        <p:nvSpPr>
+          <p:cNvPr id="15" name="Shape 13"/>
+          <p:cNvSpPr/>
+          <p:nvPr/>
+        </p:nvSpPr>
+        <p:spPr>
+          <a:xfrm>
+            <a:off x="8229600" y="2514600"/>
+            <a:ext cx="3383280" cy="1737360"/>
+          </a:xfrm>
+          <a:prstGeom prst="rect">
+            <a:avLst/>
+          </a:prstGeom>
+          <a:solidFill>
+            <a:srgbClr val="FFFFFF"/>
+          </a:solidFill>
+          <a:ln w="12700">
+            <a:solidFill>
+              <a:srgbClr val="E2E8F0"/>
+            </a:solidFill>
+            <a:prstDash val="solid"/>
+          </a:ln>
+          <a:effectLst>
+            <a:outerShdw sx="100000" sy="100000" kx="0" ky="0" algn="bl" rotWithShape="0" blurRad="114300" dist="38100" dir="8100000">
+              <a:srgbClr val="0F172A">
+                <a:alpha val="12000"/>
+              </a:srgbClr>
+            </a:outerShdw>
+          </a:effectLst>
+        </p:spPr>
+      </p:sp>
+      <p:sp>
+        <p:nvSpPr>
+          <p:cNvPr id="16" name="Shape 14"/>
+          <p:cNvSpPr/>
+          <p:nvPr/>
+        </p:nvSpPr>
+        <p:spPr>
+          <a:xfrm>
+            <a:off x="8229600" y="2514600"/>
+            <a:ext cx="3383280" cy="82296"/>
+          </a:xfrm>
+          <a:prstGeom prst="rect">
+            <a:avLst/>
+          </a:prstGeom>
+          <a:solidFill>
+            <a:srgbClr val="0EA5A4"/>
+          </a:solidFill>
+          <a:ln/>
+        </p:spPr>
+      </p:sp>
+      <p:sp>
+        <p:nvSpPr>
+          <p:cNvPr id="17" name="Text 15"/>
+          <p:cNvSpPr/>
+          <p:nvPr/>
+        </p:nvSpPr>
+        <p:spPr>
+          <a:xfrm>
+            <a:off x="8485632" y="2743200"/>
+            <a:ext cx="2926080" cy="365760"/>
+          </a:xfrm>
+          <a:prstGeom prst="rect">
+            <a:avLst/>
+          </a:prstGeom>
+          <a:noFill/>
+          <a:ln/>
+        </p:spPr>
+        <p:txBody>
+          <a:bodyPr wrap="square" lIns="0" tIns="0" rIns="0" bIns="0" rtlCol="0" anchor="ctr"/>
+          <a:lstStyle/>
+          <a:p>
+            <a:pPr indent="0" marL="0">
+              <a:buNone/>
+            </a:pPr>
+            <a:r>
+              <a:rPr lang="en-US" sz="1700" b="1" dirty="0">
+                <a:solidFill>
+                  <a:srgbClr val="1D4ED8"/>
+                </a:solidFill>
+                <a:latin typeface="Georgia" pitchFamily="34" charset="0"/>
+                <a:ea typeface="Georgia" pitchFamily="34" charset="-122"/>
+                <a:cs typeface="Georgia" pitchFamily="34" charset="-120"/>
+              </a:rPr>
+              <a:t>3 · Draft</a:t>
+            </a:r>
+            <a:endParaRPr lang="en-US" sz="1700" dirty="0"/>
+          </a:p>
+        </p:txBody>
+      </p:sp>
+      <p:sp>
+        <p:nvSpPr>
+          <p:cNvPr id="18" name="Text 16"/>
+          <p:cNvSpPr/>
+          <p:nvPr/>
+        </p:nvSpPr>
+        <p:spPr>
+          <a:xfrm>
+            <a:off x="8485632" y="3200400"/>
+            <a:ext cx="2971800" cy="960120"/>
+          </a:xfrm>
+          <a:prstGeom prst="rect">
+            <a:avLst/>
+          </a:prstGeom>
+          <a:noFill/>
+          <a:ln/>
+        </p:spPr>
+        <p:txBody>
+          <a:bodyPr wrap="square" lIns="0" tIns="0" rIns="0" bIns="0" rtlCol="0" anchor="ctr"/>
+          <a:lstStyle/>
+          <a:p>
+            <a:pPr indent="0" marL="0">
+              <a:buNone/>
+            </a:pPr>
+            <a:r>
+              <a:rPr lang="en-US" sz="1250" dirty="0">
+                <a:solidFill>
+                  <a:srgbClr val="64748B"/>
+                </a:solidFill>
+                <a:latin typeface="Calibri" pitchFamily="34" charset="0"/>
+                <a:ea typeface="Calibri" pitchFamily="34" charset="-122"/>
+                <a:cs typeface="Calibri" pitchFamily="34" charset="-120"/>
+              </a:rPr>
+              <a:t>It writes every section in your brand voice, ending with an e-sign call to action.</a:t>
+            </a:r>
+            <a:endParaRPr lang="en-US" sz="1250" dirty="0"/>
+          </a:p>
+        </p:txBody>
+      </p:sp>
+      <p:sp>
+        <p:nvSpPr>
+          <p:cNvPr id="19" name="Text 17"/>
+          <p:cNvSpPr/>
+          <p:nvPr/>
+        </p:nvSpPr>
+        <p:spPr>
+          <a:xfrm>
+            <a:off x="822960" y="4617720"/>
+            <a:ext cx="5303520" cy="411480"/>
+          </a:xfrm>
+          <a:prstGeom prst="rect">
+            <a:avLst/>
+          </a:prstGeom>
+          <a:noFill/>
+          <a:ln/>
+        </p:spPr>
+        <p:txBody>
+          <a:bodyPr wrap="square" lIns="0" tIns="0" rIns="0" bIns="0" rtlCol="0" anchor="ctr"/>
+          <a:lstStyle/>
+          <a:p>
+            <a:pPr indent="0" marL="0">
+              <a:buNone/>
+            </a:pPr>
+            <a:r>
+              <a:rPr lang="en-US" sz="1350" b="1" dirty="0">
+                <a:solidFill>
+                  <a:srgbClr val="16A34A"/>
+                </a:solidFill>
+                <a:latin typeface="Calibri" pitchFamily="34" charset="0"/>
+                <a:ea typeface="Calibri" pitchFamily="34" charset="-122"/>
+                <a:cs typeface="Calibri" pitchFamily="34" charset="-120"/>
+              </a:rPr>
+              <a:t>✓  </a:t>
+            </a:r>
+            <a:pPr indent="0" marL="0">
+              <a:buNone/>
+            </a:pPr>
+            <a:r>
+              <a:rPr lang="en-US" sz="1350" dirty="0">
+                <a:solidFill>
+                  <a:srgbClr val="1E293B"/>
+                </a:solidFill>
+                <a:latin typeface="Calibri" pitchFamily="34" charset="0"/>
+                <a:ea typeface="Calibri" pitchFamily="34" charset="-122"/>
+                <a:cs typeface="Calibri" pitchFamily="34" charset="-120"/>
+              </a:rPr>
+              <a:t>Writes as your business — your Proposal Voice</a:t>
+            </a:r>
+            <a:endParaRPr lang="en-US" sz="1350" dirty="0"/>
+          </a:p>
+        </p:txBody>
+      </p:sp>
+      <p:sp>
+        <p:nvSpPr>
+          <p:cNvPr id="20" name="Text 18"/>
+          <p:cNvSpPr/>
+          <p:nvPr/>
+        </p:nvSpPr>
+        <p:spPr>
+          <a:xfrm>
+            <a:off x="6263640" y="4617720"/>
+            <a:ext cx="5303520" cy="411480"/>
+          </a:xfrm>
+          <a:prstGeom prst="rect">
+            <a:avLst/>
+          </a:prstGeom>
+          <a:noFill/>
+          <a:ln/>
+        </p:spPr>
+        <p:txBody>
+          <a:bodyPr wrap="square" lIns="0" tIns="0" rIns="0" bIns="0" rtlCol="0" anchor="ctr"/>
+          <a:lstStyle/>
+          <a:p>
+            <a:pPr indent="0" marL="0">
+              <a:buNone/>
+            </a:pPr>
+            <a:r>
+              <a:rPr lang="en-US" sz="1350" b="1" dirty="0">
+                <a:solidFill>
+                  <a:srgbClr val="16A34A"/>
+                </a:solidFill>
+                <a:latin typeface="Calibri" pitchFamily="34" charset="0"/>
+                <a:ea typeface="Calibri" pitchFamily="34" charset="-122"/>
+                <a:cs typeface="Calibri" pitchFamily="34" charset="-120"/>
+              </a:rPr>
+              <a:t>✓  </a:t>
+            </a:r>
+            <a:pPr indent="0" marL="0">
+              <a:buNone/>
+            </a:pPr>
+            <a:r>
+              <a:rPr lang="en-US" sz="1350" dirty="0">
+                <a:solidFill>
+                  <a:srgbClr val="1E293B"/>
+                </a:solidFill>
+                <a:latin typeface="Calibri" pitchFamily="34" charset="0"/>
+                <a:ea typeface="Calibri" pitchFamily="34" charset="-122"/>
+                <a:cs typeface="Calibri" pitchFamily="34" charset="-120"/>
+              </a:rPr>
+              <a:t>Uses your private Client Notes to target pain points</a:t>
+            </a:r>
+            <a:endParaRPr lang="en-US" sz="1350" dirty="0"/>
+          </a:p>
+        </p:txBody>
+      </p:sp>
+      <p:sp>
+        <p:nvSpPr>
+          <p:cNvPr id="21" name="Text 19"/>
+          <p:cNvSpPr/>
+          <p:nvPr/>
+        </p:nvSpPr>
+        <p:spPr>
+          <a:xfrm>
+            <a:off x="822960" y="5093208"/>
+            <a:ext cx="5303520" cy="411480"/>
+          </a:xfrm>
+          <a:prstGeom prst="rect">
+            <a:avLst/>
+          </a:prstGeom>
+          <a:noFill/>
+          <a:ln/>
+        </p:spPr>
+        <p:txBody>
+          <a:bodyPr wrap="square" lIns="0" tIns="0" rIns="0" bIns="0" rtlCol="0" anchor="ctr"/>
+          <a:lstStyle/>
+          <a:p>
+            <a:pPr indent="0" marL="0">
+              <a:buNone/>
+            </a:pPr>
+            <a:r>
+              <a:rPr lang="en-US" sz="1350" b="1" dirty="0">
+                <a:solidFill>
+                  <a:srgbClr val="16A34A"/>
+                </a:solidFill>
+                <a:latin typeface="Calibri" pitchFamily="34" charset="0"/>
+                <a:ea typeface="Calibri" pitchFamily="34" charset="-122"/>
+                <a:cs typeface="Calibri" pitchFamily="34" charset="-120"/>
+              </a:rPr>
+              <a:t>✓  </a:t>
+            </a:r>
+            <a:pPr indent="0" marL="0">
+              <a:buNone/>
+            </a:pPr>
+            <a:r>
+              <a:rPr lang="en-US" sz="1350" dirty="0">
+                <a:solidFill>
+                  <a:srgbClr val="1E293B"/>
+                </a:solidFill>
+                <a:latin typeface="Calibri" pitchFamily="34" charset="0"/>
+                <a:ea typeface="Calibri" pitchFamily="34" charset="-122"/>
+                <a:cs typeface="Calibri" pitchFamily="34" charset="-120"/>
+              </a:rPr>
+              <a:t>Reads pricing scenarios directly — no re-keying</a:t>
+            </a:r>
+            <a:endParaRPr lang="en-US" sz="1350" dirty="0"/>
+          </a:p>
+        </p:txBody>
+      </p:sp>
+      <p:sp>
+        <p:nvSpPr>
+          <p:cNvPr id="22" name="Text 20"/>
+          <p:cNvSpPr/>
+          <p:nvPr/>
+        </p:nvSpPr>
+        <p:spPr>
+          <a:xfrm>
+            <a:off x="6263640" y="5093208"/>
+            <a:ext cx="5303520" cy="411480"/>
+          </a:xfrm>
+          <a:prstGeom prst="rect">
+            <a:avLst/>
+          </a:prstGeom>
+          <a:noFill/>
+          <a:ln/>
+        </p:spPr>
+        <p:txBody>
+          <a:bodyPr wrap="square" lIns="0" tIns="0" rIns="0" bIns="0" rtlCol="0" anchor="ctr"/>
+          <a:lstStyle/>
+          <a:p>
+            <a:pPr indent="0" marL="0">
+              <a:buNone/>
+            </a:pPr>
+            <a:r>
+              <a:rPr lang="en-US" sz="1350" b="1" dirty="0">
+                <a:solidFill>
+                  <a:srgbClr val="16A34A"/>
+                </a:solidFill>
+                <a:latin typeface="Calibri" pitchFamily="34" charset="0"/>
+                <a:ea typeface="Calibri" pitchFamily="34" charset="-122"/>
+                <a:cs typeface="Calibri" pitchFamily="34" charset="-120"/>
+              </a:rPr>
+              <a:t>✓  </a:t>
+            </a:r>
+            <a:pPr indent="0" marL="0">
+              <a:buNone/>
+            </a:pPr>
+            <a:r>
+              <a:rPr lang="en-US" sz="1350" dirty="0">
+                <a:solidFill>
+                  <a:srgbClr val="1E293B"/>
+                </a:solidFill>
+                <a:latin typeface="Calibri" pitchFamily="34" charset="0"/>
+                <a:ea typeface="Calibri" pitchFamily="34" charset="-122"/>
+                <a:cs typeface="Calibri" pitchFamily="34" charset="-120"/>
+              </a:rPr>
+              <a:t>Preview &amp; edit before anything is inserted</a:t>
+            </a:r>
+            <a:endParaRPr lang="en-US" sz="1350" dirty="0"/>
+          </a:p>
+        </p:txBody>
+      </p:sp>
+      <p:sp>
+        <p:nvSpPr>
+          <p:cNvPr id="23" name="Text 21"/>
+          <p:cNvSpPr/>
+          <p:nvPr/>
+        </p:nvSpPr>
+        <p:spPr>
+          <a:xfrm>
+            <a:off x="822960" y="5715000"/>
+            <a:ext cx="10424160" cy="365760"/>
+          </a:xfrm>
+          <a:prstGeom prst="rect">
+            <a:avLst/>
+          </a:prstGeom>
+          <a:noFill/>
+          <a:ln/>
+        </p:spPr>
+        <p:txBody>
+          <a:bodyPr wrap="square" lIns="0" tIns="0" rIns="0" bIns="0" rtlCol="0" anchor="ctr"/>
+          <a:lstStyle/>
+          <a:p>
+            <a:pPr indent="0" marL="0">
+              <a:buNone/>
+            </a:pPr>
+            <a:r>
+              <a:rPr lang="en-US" sz="1300" i="1" dirty="0">
+                <a:solidFill>
+                  <a:srgbClr val="1D4ED8"/>
+                </a:solidFill>
+                <a:latin typeface="Calibri" pitchFamily="34" charset="0"/>
+                <a:ea typeface="Calibri" pitchFamily="34" charset="-122"/>
+                <a:cs typeface="Calibri" pitchFamily="34" charset="-120"/>
+              </a:rPr>
+              <a:t>Plus inline “Ask AI” to improve, expand, shorten, or re-tone any selection.</a:t>
+            </a:r>
+            <a:endParaRPr lang="en-US" sz="1300" dirty="0"/>
+          </a:p>
+        </p:txBody>
+      </p:sp>
+    </p:spTree>
+  </p:cSld>
+  <p:clrMapOvr>
+    <a:masterClrMapping/>
+  </p:clrMapOvr>
+</p:sld>
+</file>
+
+<file path=ppt/slides/slide6.xml><?xml version="1.0" encoding="utf-8"?>
+<p:sld xmlns:a="http://schemas.openxmlformats.org/drawingml/2006/main" xmlns:r="http://schemas.openxmlformats.org/officeDocument/2006/relationships" xmlns:p="http://schemas.openxmlformats.org/presentationml/2006/main">
+  <p:cSld name="Slide 6">
+    <p:bg>
+      <p:bgPr>
+        <a:solidFill>
           <a:srgbClr val="0B1F3A"/>
         </a:solidFill>
       </p:bgPr>
@@ -5114,9 +6071,9 @@
 </p:sld>
 </file>
 
-<file path=ppt/slides/slide6.xml><?xml version="1.0" encoding="utf-8"?>
+<file path=ppt/slides/slide7.xml><?xml version="1.0" encoding="utf-8"?>
 <p:sld xmlns:a="http://schemas.openxmlformats.org/drawingml/2006/main" xmlns:r="http://schemas.openxmlformats.org/officeDocument/2006/relationships" xmlns:p="http://schemas.openxmlformats.org/presentationml/2006/main">
-  <p:cSld name="Slide 6">
+  <p:cSld name="Slide 7">
     <p:bg>
       <p:bgPr>
         <a:solidFill>
@@ -6477,9 +7434,9 @@
 </p:sld>
 </file>
 
-<file path=ppt/slides/slide7.xml><?xml version="1.0" encoding="utf-8"?>
+<file path=ppt/slides/slide8.xml><?xml version="1.0" encoding="utf-8"?>
 <p:sld xmlns:a="http://schemas.openxmlformats.org/drawingml/2006/main" xmlns:r="http://schemas.openxmlformats.org/officeDocument/2006/relationships" xmlns:p="http://schemas.openxmlformats.org/presentationml/2006/main">
-  <p:cSld name="Slide 7">
+  <p:cSld name="Slide 8">
     <p:bg>
       <p:bgPr>
         <a:solidFill>

</xml_diff>

<commit_message>
Deck: update pricing slide to v2 (5 fixed tiers, no seat add-ons)
Replace the v1 4-tier pricing (Pay-per-use/Starter/Team/Team Ultra with
$10/seat add-ons) with the frozen v2 model from pricing-model-design.md §2:
- 5 tiers: Pay-per-use $9/doc · Starter $30 (5 docs) · Standard $50 (10) ·
  Pro $80 (25, Most Popular) · Ultra $150 (50).
- Users fixed per plan (no seat add-ons); flat $3/doc overage on every tier;
  AI proposal drafting included on every plan (fair-use).
- Responsive 5-card layout (auto-centered) + updated footer note.
Rebuilt ultraquote-deck.pptx.

Co-Authored-By: Claude Opus 4.8 <noreply@anthropic.com>
</commit_message>
<xml_diff>
--- a/marketing-materials/ultraquote-deck.pptx
+++ b/marketing-materials/ultraquote-deck.pptx
@@ -6220,8 +6220,8 @@
         </p:nvSpPr>
         <p:spPr>
           <a:xfrm>
-            <a:off x="822960" y="1920240"/>
-            <a:ext cx="2606040" cy="3566160"/>
+            <a:off x="484632" y="1965960"/>
+            <a:ext cx="2011680" cy="3657600"/>
           </a:xfrm>
           <a:prstGeom prst="rect">
             <a:avLst/>
@@ -6252,8 +6252,8 @@
         </p:nvSpPr>
         <p:spPr>
           <a:xfrm>
-            <a:off x="822960" y="1920240"/>
-            <a:ext cx="2606040" cy="73152"/>
+            <a:off x="484632" y="1965960"/>
+            <a:ext cx="2011680" cy="73152"/>
           </a:xfrm>
           <a:prstGeom prst="rect">
             <a:avLst/>
@@ -6272,24 +6272,24 @@
         </p:nvSpPr>
         <p:spPr>
           <a:xfrm>
-            <a:off x="1051560" y="2212848"/>
-            <a:ext cx="2194560" cy="365760"/>
-          </a:xfrm>
-          <a:prstGeom prst="rect">
-            <a:avLst/>
-          </a:prstGeom>
-          <a:noFill/>
-          <a:ln/>
-        </p:spPr>
-        <p:txBody>
-          <a:bodyPr wrap="square" lIns="0" tIns="0" rIns="0" bIns="0" rtlCol="0" anchor="ctr"/>
-          <a:lstStyle/>
-          <a:p>
-            <a:pPr indent="0" marL="0">
-              <a:buNone/>
-            </a:pPr>
-            <a:r>
-              <a:rPr lang="en-US" sz="1800" b="1" dirty="0">
+            <a:off x="667512" y="2240280"/>
+            <a:ext cx="1645920" cy="365760"/>
+          </a:xfrm>
+          <a:prstGeom prst="rect">
+            <a:avLst/>
+          </a:prstGeom>
+          <a:noFill/>
+          <a:ln/>
+        </p:spPr>
+        <p:txBody>
+          <a:bodyPr wrap="square" lIns="0" tIns="0" rIns="0" bIns="0" rtlCol="0" anchor="ctr"/>
+          <a:lstStyle/>
+          <a:p>
+            <a:pPr indent="0" marL="0">
+              <a:buNone/>
+            </a:pPr>
+            <a:r>
+              <a:rPr lang="en-US" sz="1600" b="1" dirty="0">
                 <a:solidFill>
                   <a:srgbClr val="0B1F3A"/>
                 </a:solidFill>
@@ -6299,7 +6299,7 @@
               </a:rPr>
               <a:t>Pay-per-use</a:t>
             </a:r>
-            <a:endParaRPr lang="en-US" sz="1800" dirty="0"/>
+            <a:endParaRPr lang="en-US" sz="1600" dirty="0"/>
           </a:p>
         </p:txBody>
       </p:sp>
@@ -6311,24 +6311,24 @@
         </p:nvSpPr>
         <p:spPr>
           <a:xfrm>
-            <a:off x="1051560" y="2624328"/>
-            <a:ext cx="2286000" cy="548640"/>
-          </a:xfrm>
-          <a:prstGeom prst="rect">
-            <a:avLst/>
-          </a:prstGeom>
-          <a:noFill/>
-          <a:ln/>
-        </p:spPr>
-        <p:txBody>
-          <a:bodyPr wrap="square" lIns="0" tIns="0" rIns="0" bIns="0" rtlCol="0" anchor="ctr"/>
-          <a:lstStyle/>
-          <a:p>
-            <a:pPr indent="0" marL="0">
-              <a:buNone/>
-            </a:pPr>
-            <a:r>
-              <a:rPr lang="en-US" sz="3400" b="1" dirty="0">
+            <a:off x="667512" y="2624328"/>
+            <a:ext cx="1645920" cy="502920"/>
+          </a:xfrm>
+          <a:prstGeom prst="rect">
+            <a:avLst/>
+          </a:prstGeom>
+          <a:noFill/>
+          <a:ln/>
+        </p:spPr>
+        <p:txBody>
+          <a:bodyPr wrap="square" lIns="0" tIns="0" rIns="0" bIns="0" rtlCol="0" anchor="ctr"/>
+          <a:lstStyle/>
+          <a:p>
+            <a:pPr indent="0" marL="0">
+              <a:buNone/>
+            </a:pPr>
+            <a:r>
+              <a:rPr lang="en-US" sz="2800" b="1" dirty="0">
                 <a:solidFill>
                   <a:srgbClr val="0B1F3A"/>
                 </a:solidFill>
@@ -6342,7 +6342,7 @@
               <a:buNone/>
             </a:pPr>
             <a:r>
-              <a:rPr lang="en-US" sz="1200" dirty="0">
+              <a:rPr lang="en-US" sz="1050" dirty="0">
                 <a:solidFill>
                   <a:srgbClr val="64748B"/>
                 </a:solidFill>
@@ -6352,7 +6352,7 @@
               </a:rPr>
               <a:t> / signed doc</a:t>
             </a:r>
-            <a:endParaRPr lang="en-US" sz="3400" dirty="0"/>
+            <a:endParaRPr lang="en-US" sz="2800" dirty="0"/>
           </a:p>
         </p:txBody>
       </p:sp>
@@ -6364,24 +6364,24 @@
         </p:nvSpPr>
         <p:spPr>
           <a:xfrm>
-            <a:off x="1051560" y="3264408"/>
-            <a:ext cx="2240280" cy="320040"/>
-          </a:xfrm>
-          <a:prstGeom prst="rect">
-            <a:avLst/>
-          </a:prstGeom>
-          <a:noFill/>
-          <a:ln/>
-        </p:spPr>
-        <p:txBody>
-          <a:bodyPr wrap="square" lIns="0" tIns="0" rIns="0" bIns="0" rtlCol="0" anchor="ctr"/>
-          <a:lstStyle/>
-          <a:p>
-            <a:pPr indent="0" marL="0">
-              <a:buNone/>
-            </a:pPr>
-            <a:r>
-              <a:rPr lang="en-US" sz="1150" b="1" dirty="0">
+            <a:off x="667512" y="3227832"/>
+            <a:ext cx="1645920" cy="320040"/>
+          </a:xfrm>
+          <a:prstGeom prst="rect">
+            <a:avLst/>
+          </a:prstGeom>
+          <a:noFill/>
+          <a:ln/>
+        </p:spPr>
+        <p:txBody>
+          <a:bodyPr wrap="square" lIns="0" tIns="0" rIns="0" bIns="0" rtlCol="0" anchor="ctr"/>
+          <a:lstStyle/>
+          <a:p>
+            <a:pPr indent="0" marL="0">
+              <a:buNone/>
+            </a:pPr>
+            <a:r>
+              <a:rPr lang="en-US" sz="1050" b="1" dirty="0">
                 <a:solidFill>
                   <a:srgbClr val="0F5F5C"/>
                 </a:solidFill>
@@ -6391,7 +6391,7 @@
               </a:rPr>
               <a:t>$0 base · pay as you go</a:t>
             </a:r>
-            <a:endParaRPr lang="en-US" sz="1150" dirty="0"/>
+            <a:endParaRPr lang="en-US" sz="1050" dirty="0"/>
           </a:p>
         </p:txBody>
       </p:sp>
@@ -6403,28 +6403,28 @@
         </p:nvSpPr>
         <p:spPr>
           <a:xfrm>
-            <a:off x="1051560" y="3630168"/>
-            <a:ext cx="2286000" cy="1554480"/>
-          </a:xfrm>
-          <a:prstGeom prst="rect">
-            <a:avLst/>
-          </a:prstGeom>
-          <a:noFill/>
-          <a:ln/>
-        </p:spPr>
-        <p:txBody>
-          <a:bodyPr wrap="square" lIns="0" tIns="0" rIns="0" bIns="0" rtlCol="0" anchor="ctr"/>
-          <a:lstStyle/>
-          <a:p>
-            <a:pPr marL="177800" indent="-177800">
+            <a:off x="667512" y="3611880"/>
+            <a:ext cx="1645920" cy="1737360"/>
+          </a:xfrm>
+          <a:prstGeom prst="rect">
+            <a:avLst/>
+          </a:prstGeom>
+          <a:noFill/>
+          <a:ln/>
+        </p:spPr>
+        <p:txBody>
+          <a:bodyPr wrap="square" lIns="0" tIns="0" rIns="0" bIns="0" rtlCol="0" anchor="ctr"/>
+          <a:lstStyle/>
+          <a:p>
+            <a:pPr marL="152400" indent="-152400">
               <a:spcAft>
-                <a:spcPts val="500"/>
+                <a:spcPts val="400"/>
               </a:spcAft>
               <a:buSzPct val="100000"/>
               <a:buChar char="✓"/>
             </a:pPr>
             <a:r>
-              <a:rPr lang="en-US" sz="1150" dirty="0">
+              <a:rPr lang="en-US" sz="1050" dirty="0">
                 <a:solidFill>
                   <a:srgbClr val="1E293B"/>
                 </a:solidFill>
@@ -6432,20 +6432,20 @@
                 <a:ea typeface="Calibri" pitchFamily="34" charset="-122"/>
                 <a:cs typeface="Calibri" pitchFamily="34" charset="-120"/>
               </a:rPr>
-              <a:t>1 user (owner)</a:t>
-            </a:r>
-            <a:endParaRPr lang="en-US" sz="1150" dirty="0"/>
-          </a:p>
-          <a:p>
-            <a:pPr marL="177800" indent="-177800">
+              <a:t>1 user</a:t>
+            </a:r>
+            <a:endParaRPr lang="en-US" sz="1050" dirty="0"/>
+          </a:p>
+          <a:p>
+            <a:pPr marL="152400" indent="-152400">
               <a:spcAft>
-                <a:spcPts val="500"/>
+                <a:spcPts val="400"/>
               </a:spcAft>
               <a:buSzPct val="100000"/>
               <a:buChar char="✓"/>
             </a:pPr>
             <a:r>
-              <a:rPr lang="en-US" sz="1150" dirty="0">
+              <a:rPr lang="en-US" sz="1050" dirty="0">
                 <a:solidFill>
                   <a:srgbClr val="1E293B"/>
                 </a:solidFill>
@@ -6455,18 +6455,18 @@
               </a:rPr>
               <a:t>Unlimited quotes</a:t>
             </a:r>
-            <a:endParaRPr lang="en-US" sz="1150" dirty="0"/>
-          </a:p>
-          <a:p>
-            <a:pPr marL="177800" indent="-177800">
+            <a:endParaRPr lang="en-US" sz="1050" dirty="0"/>
+          </a:p>
+          <a:p>
+            <a:pPr marL="152400" indent="-152400">
               <a:spcAft>
-                <a:spcPts val="500"/>
+                <a:spcPts val="400"/>
               </a:spcAft>
               <a:buSzPct val="100000"/>
               <a:buChar char="✓"/>
             </a:pPr>
             <a:r>
-              <a:rPr lang="en-US" sz="1150" dirty="0">
+              <a:rPr lang="en-US" sz="1050" dirty="0">
                 <a:solidFill>
                   <a:srgbClr val="1E293B"/>
                 </a:solidFill>
@@ -6476,18 +6476,18 @@
               </a:rPr>
               <a:t>All features</a:t>
             </a:r>
-            <a:endParaRPr lang="en-US" sz="1150" dirty="0"/>
-          </a:p>
-          <a:p>
-            <a:pPr marL="177800" indent="-177800">
+            <a:endParaRPr lang="en-US" sz="1050" dirty="0"/>
+          </a:p>
+          <a:p>
+            <a:pPr marL="152400" indent="-152400">
               <a:spcAft>
-                <a:spcPts val="500"/>
+                <a:spcPts val="400"/>
               </a:spcAft>
               <a:buSzPct val="100000"/>
               <a:buChar char="✓"/>
             </a:pPr>
             <a:r>
-              <a:rPr lang="en-US" sz="1150" dirty="0">
+              <a:rPr lang="en-US" sz="1050" dirty="0">
                 <a:solidFill>
                   <a:srgbClr val="1E293B"/>
                 </a:solidFill>
@@ -6497,7 +6497,7 @@
               </a:rPr>
               <a:t>No commitment</a:t>
             </a:r>
-            <a:endParaRPr lang="en-US" sz="1150" dirty="0"/>
+            <a:endParaRPr lang="en-US" sz="1050" dirty="0"/>
           </a:p>
         </p:txBody>
       </p:sp>
@@ -6509,8 +6509,8 @@
         </p:nvSpPr>
         <p:spPr>
           <a:xfrm>
-            <a:off x="3611880" y="1920240"/>
-            <a:ext cx="2606040" cy="3566160"/>
+            <a:off x="2779776" y="1965960"/>
+            <a:ext cx="2011680" cy="3657600"/>
           </a:xfrm>
           <a:prstGeom prst="rect">
             <a:avLst/>
@@ -6541,8 +6541,8 @@
         </p:nvSpPr>
         <p:spPr>
           <a:xfrm>
-            <a:off x="3611880" y="1920240"/>
-            <a:ext cx="2606040" cy="73152"/>
+            <a:off x="2779776" y="1965960"/>
+            <a:ext cx="2011680" cy="73152"/>
           </a:xfrm>
           <a:prstGeom prst="rect">
             <a:avLst/>
@@ -6561,24 +6561,24 @@
         </p:nvSpPr>
         <p:spPr>
           <a:xfrm>
-            <a:off x="3840480" y="2212848"/>
-            <a:ext cx="2194560" cy="365760"/>
-          </a:xfrm>
-          <a:prstGeom prst="rect">
-            <a:avLst/>
-          </a:prstGeom>
-          <a:noFill/>
-          <a:ln/>
-        </p:spPr>
-        <p:txBody>
-          <a:bodyPr wrap="square" lIns="0" tIns="0" rIns="0" bIns="0" rtlCol="0" anchor="ctr"/>
-          <a:lstStyle/>
-          <a:p>
-            <a:pPr indent="0" marL="0">
-              <a:buNone/>
-            </a:pPr>
-            <a:r>
-              <a:rPr lang="en-US" sz="1800" b="1" dirty="0">
+            <a:off x="2962656" y="2240280"/>
+            <a:ext cx="1645920" cy="365760"/>
+          </a:xfrm>
+          <a:prstGeom prst="rect">
+            <a:avLst/>
+          </a:prstGeom>
+          <a:noFill/>
+          <a:ln/>
+        </p:spPr>
+        <p:txBody>
+          <a:bodyPr wrap="square" lIns="0" tIns="0" rIns="0" bIns="0" rtlCol="0" anchor="ctr"/>
+          <a:lstStyle/>
+          <a:p>
+            <a:pPr indent="0" marL="0">
+              <a:buNone/>
+            </a:pPr>
+            <a:r>
+              <a:rPr lang="en-US" sz="1600" b="1" dirty="0">
                 <a:solidFill>
                   <a:srgbClr val="0B1F3A"/>
                 </a:solidFill>
@@ -6588,7 +6588,7 @@
               </a:rPr>
               <a:t>Starter</a:t>
             </a:r>
-            <a:endParaRPr lang="en-US" sz="1800" dirty="0"/>
+            <a:endParaRPr lang="en-US" sz="1600" dirty="0"/>
           </a:p>
         </p:txBody>
       </p:sp>
@@ -6600,24 +6600,24 @@
         </p:nvSpPr>
         <p:spPr>
           <a:xfrm>
-            <a:off x="3840480" y="2624328"/>
-            <a:ext cx="2286000" cy="548640"/>
-          </a:xfrm>
-          <a:prstGeom prst="rect">
-            <a:avLst/>
-          </a:prstGeom>
-          <a:noFill/>
-          <a:ln/>
-        </p:spPr>
-        <p:txBody>
-          <a:bodyPr wrap="square" lIns="0" tIns="0" rIns="0" bIns="0" rtlCol="0" anchor="ctr"/>
-          <a:lstStyle/>
-          <a:p>
-            <a:pPr indent="0" marL="0">
-              <a:buNone/>
-            </a:pPr>
-            <a:r>
-              <a:rPr lang="en-US" sz="3400" b="1" dirty="0">
+            <a:off x="2962656" y="2624328"/>
+            <a:ext cx="1645920" cy="502920"/>
+          </a:xfrm>
+          <a:prstGeom prst="rect">
+            <a:avLst/>
+          </a:prstGeom>
+          <a:noFill/>
+          <a:ln/>
+        </p:spPr>
+        <p:txBody>
+          <a:bodyPr wrap="square" lIns="0" tIns="0" rIns="0" bIns="0" rtlCol="0" anchor="ctr"/>
+          <a:lstStyle/>
+          <a:p>
+            <a:pPr indent="0" marL="0">
+              <a:buNone/>
+            </a:pPr>
+            <a:r>
+              <a:rPr lang="en-US" sz="2800" b="1" dirty="0">
                 <a:solidFill>
                   <a:srgbClr val="0B1F3A"/>
                 </a:solidFill>
@@ -6625,13 +6625,13 @@
                 <a:ea typeface="Georgia" pitchFamily="34" charset="-122"/>
                 <a:cs typeface="Georgia" pitchFamily="34" charset="-120"/>
               </a:rPr>
-              <a:t>$29</a:t>
-            </a:r>
-            <a:pPr indent="0" marL="0">
-              <a:buNone/>
-            </a:pPr>
-            <a:r>
-              <a:rPr lang="en-US" sz="1200" dirty="0">
+              <a:t>$30</a:t>
+            </a:r>
+            <a:pPr indent="0" marL="0">
+              <a:buNone/>
+            </a:pPr>
+            <a:r>
+              <a:rPr lang="en-US" sz="1050" dirty="0">
                 <a:solidFill>
                   <a:srgbClr val="64748B"/>
                 </a:solidFill>
@@ -6641,7 +6641,7 @@
               </a:rPr>
               <a:t> / mo</a:t>
             </a:r>
-            <a:endParaRPr lang="en-US" sz="3400" dirty="0"/>
+            <a:endParaRPr lang="en-US" sz="2800" dirty="0"/>
           </a:p>
         </p:txBody>
       </p:sp>
@@ -6653,24 +6653,24 @@
         </p:nvSpPr>
         <p:spPr>
           <a:xfrm>
-            <a:off x="3840480" y="3264408"/>
-            <a:ext cx="2240280" cy="320040"/>
-          </a:xfrm>
-          <a:prstGeom prst="rect">
-            <a:avLst/>
-          </a:prstGeom>
-          <a:noFill/>
-          <a:ln/>
-        </p:spPr>
-        <p:txBody>
-          <a:bodyPr wrap="square" lIns="0" tIns="0" rIns="0" bIns="0" rtlCol="0" anchor="ctr"/>
-          <a:lstStyle/>
-          <a:p>
-            <a:pPr indent="0" marL="0">
-              <a:buNone/>
-            </a:pPr>
-            <a:r>
-              <a:rPr lang="en-US" sz="1150" b="1" dirty="0">
+            <a:off x="2962656" y="3227832"/>
+            <a:ext cx="1645920" cy="320040"/>
+          </a:xfrm>
+          <a:prstGeom prst="rect">
+            <a:avLst/>
+          </a:prstGeom>
+          <a:noFill/>
+          <a:ln/>
+        </p:spPr>
+        <p:txBody>
+          <a:bodyPr wrap="square" lIns="0" tIns="0" rIns="0" bIns="0" rtlCol="0" anchor="ctr"/>
+          <a:lstStyle/>
+          <a:p>
+            <a:pPr indent="0" marL="0">
+              <a:buNone/>
+            </a:pPr>
+            <a:r>
+              <a:rPr lang="en-US" sz="1050" b="1" dirty="0">
                 <a:solidFill>
                   <a:srgbClr val="0F5F5C"/>
                 </a:solidFill>
@@ -6678,9 +6678,9 @@
                 <a:ea typeface="Calibri" pitchFamily="34" charset="-122"/>
                 <a:cs typeface="Calibri" pitchFamily="34" charset="-120"/>
               </a:rPr>
-              <a:t>10 signed docs included</a:t>
-            </a:r>
-            <a:endParaRPr lang="en-US" sz="1150" dirty="0"/>
+              <a:t>5 signed docs / mo</a:t>
+            </a:r>
+            <a:endParaRPr lang="en-US" sz="1050" dirty="0"/>
           </a:p>
         </p:txBody>
       </p:sp>
@@ -6692,28 +6692,28 @@
         </p:nvSpPr>
         <p:spPr>
           <a:xfrm>
-            <a:off x="3840480" y="3630168"/>
-            <a:ext cx="2286000" cy="1554480"/>
-          </a:xfrm>
-          <a:prstGeom prst="rect">
-            <a:avLst/>
-          </a:prstGeom>
-          <a:noFill/>
-          <a:ln/>
-        </p:spPr>
-        <p:txBody>
-          <a:bodyPr wrap="square" lIns="0" tIns="0" rIns="0" bIns="0" rtlCol="0" anchor="ctr"/>
-          <a:lstStyle/>
-          <a:p>
-            <a:pPr marL="177800" indent="-177800">
+            <a:off x="2962656" y="3611880"/>
+            <a:ext cx="1645920" cy="1737360"/>
+          </a:xfrm>
+          <a:prstGeom prst="rect">
+            <a:avLst/>
+          </a:prstGeom>
+          <a:noFill/>
+          <a:ln/>
+        </p:spPr>
+        <p:txBody>
+          <a:bodyPr wrap="square" lIns="0" tIns="0" rIns="0" bIns="0" rtlCol="0" anchor="ctr"/>
+          <a:lstStyle/>
+          <a:p>
+            <a:pPr marL="152400" indent="-152400">
               <a:spcAft>
-                <a:spcPts val="500"/>
+                <a:spcPts val="400"/>
               </a:spcAft>
               <a:buSzPct val="100000"/>
               <a:buChar char="✓"/>
             </a:pPr>
             <a:r>
-              <a:rPr lang="en-US" sz="1150" dirty="0">
+              <a:rPr lang="en-US" sz="1050" dirty="0">
                 <a:solidFill>
                   <a:srgbClr val="1E293B"/>
                 </a:solidFill>
@@ -6721,20 +6721,20 @@
                 <a:ea typeface="Calibri" pitchFamily="34" charset="-122"/>
                 <a:cs typeface="Calibri" pitchFamily="34" charset="-120"/>
               </a:rPr>
-              <a:t>1 user · up to 3</a:t>
-            </a:r>
-            <a:endParaRPr lang="en-US" sz="1150" dirty="0"/>
-          </a:p>
-          <a:p>
-            <a:pPr marL="177800" indent="-177800">
+              <a:t>1 user</a:t>
+            </a:r>
+            <a:endParaRPr lang="en-US" sz="1050" dirty="0"/>
+          </a:p>
+          <a:p>
+            <a:pPr marL="152400" indent="-152400">
               <a:spcAft>
-                <a:spcPts val="500"/>
+                <a:spcPts val="400"/>
               </a:spcAft>
               <a:buSzPct val="100000"/>
               <a:buChar char="✓"/>
             </a:pPr>
             <a:r>
-              <a:rPr lang="en-US" sz="1150" dirty="0">
+              <a:rPr lang="en-US" sz="1050" dirty="0">
                 <a:solidFill>
                   <a:srgbClr val="1E293B"/>
                 </a:solidFill>
@@ -6742,20 +6742,20 @@
                 <a:ea typeface="Calibri" pitchFamily="34" charset="-122"/>
                 <a:cs typeface="Calibri" pitchFamily="34" charset="-120"/>
               </a:rPr>
-              <a:t>+$10/seat (+5 docs)</a:t>
-            </a:r>
-            <a:endParaRPr lang="en-US" sz="1150" dirty="0"/>
-          </a:p>
-          <a:p>
-            <a:pPr marL="177800" indent="-177800">
+              <a:t>$3 / extra doc</a:t>
+            </a:r>
+            <a:endParaRPr lang="en-US" sz="1050" dirty="0"/>
+          </a:p>
+          <a:p>
+            <a:pPr marL="152400" indent="-152400">
               <a:spcAft>
-                <a:spcPts val="500"/>
+                <a:spcPts val="400"/>
               </a:spcAft>
               <a:buSzPct val="100000"/>
               <a:buChar char="✓"/>
             </a:pPr>
             <a:r>
-              <a:rPr lang="en-US" sz="1150" dirty="0">
+              <a:rPr lang="en-US" sz="1050" dirty="0">
                 <a:solidFill>
                   <a:srgbClr val="1E293B"/>
                 </a:solidFill>
@@ -6763,20 +6763,20 @@
                 <a:ea typeface="Calibri" pitchFamily="34" charset="-122"/>
                 <a:cs typeface="Calibri" pitchFamily="34" charset="-120"/>
               </a:rPr>
-              <a:t>$3 per extra doc</a:t>
-            </a:r>
-            <a:endParaRPr lang="en-US" sz="1150" dirty="0"/>
-          </a:p>
-          <a:p>
-            <a:pPr marL="177800" indent="-177800">
+              <a:t>Unlimited quotes</a:t>
+            </a:r>
+            <a:endParaRPr lang="en-US" sz="1050" dirty="0"/>
+          </a:p>
+          <a:p>
+            <a:pPr marL="152400" indent="-152400">
               <a:spcAft>
-                <a:spcPts val="500"/>
+                <a:spcPts val="400"/>
               </a:spcAft>
               <a:buSzPct val="100000"/>
               <a:buChar char="✓"/>
             </a:pPr>
             <a:r>
-              <a:rPr lang="en-US" sz="1150" dirty="0">
+              <a:rPr lang="en-US" sz="1050" dirty="0">
                 <a:solidFill>
                   <a:srgbClr val="1E293B"/>
                 </a:solidFill>
@@ -6784,9 +6784,9 @@
                 <a:ea typeface="Calibri" pitchFamily="34" charset="-122"/>
                 <a:cs typeface="Calibri" pitchFamily="34" charset="-120"/>
               </a:rPr>
-              <a:t>Unlimited quotes</a:t>
-            </a:r>
-            <a:endParaRPr lang="en-US" sz="1150" dirty="0"/>
+              <a:t>All features</a:t>
+            </a:r>
+            <a:endParaRPr lang="en-US" sz="1050" dirty="0"/>
           </a:p>
         </p:txBody>
       </p:sp>
@@ -6798,8 +6798,276 @@
         </p:nvSpPr>
         <p:spPr>
           <a:xfrm>
-            <a:off x="6400800" y="1783080"/>
-            <a:ext cx="2606040" cy="3840480"/>
+            <a:off x="5074920" y="1965960"/>
+            <a:ext cx="2011680" cy="3657600"/>
+          </a:xfrm>
+          <a:prstGeom prst="rect">
+            <a:avLst/>
+          </a:prstGeom>
+          <a:solidFill>
+            <a:srgbClr val="FFFFFF"/>
+          </a:solidFill>
+          <a:ln w="12700">
+            <a:solidFill>
+              <a:srgbClr val="E2E8F0"/>
+            </a:solidFill>
+            <a:prstDash val="solid"/>
+          </a:ln>
+          <a:effectLst>
+            <a:outerShdw sx="100000" sy="100000" kx="0" ky="0" algn="bl" rotWithShape="0" blurRad="114300" dist="38100" dir="8100000">
+              <a:srgbClr val="0F172A">
+                <a:alpha val="12000"/>
+              </a:srgbClr>
+            </a:outerShdw>
+          </a:effectLst>
+        </p:spPr>
+      </p:sp>
+      <p:sp>
+        <p:nvSpPr>
+          <p:cNvPr id="18" name="Shape 16"/>
+          <p:cNvSpPr/>
+          <p:nvPr/>
+        </p:nvSpPr>
+        <p:spPr>
+          <a:xfrm>
+            <a:off x="5074920" y="1965960"/>
+            <a:ext cx="2011680" cy="73152"/>
+          </a:xfrm>
+          <a:prstGeom prst="rect">
+            <a:avLst/>
+          </a:prstGeom>
+          <a:solidFill>
+            <a:srgbClr val="0EA5A4"/>
+          </a:solidFill>
+          <a:ln/>
+        </p:spPr>
+      </p:sp>
+      <p:sp>
+        <p:nvSpPr>
+          <p:cNvPr id="19" name="Text 17"/>
+          <p:cNvSpPr/>
+          <p:nvPr/>
+        </p:nvSpPr>
+        <p:spPr>
+          <a:xfrm>
+            <a:off x="5257800" y="2240280"/>
+            <a:ext cx="1645920" cy="365760"/>
+          </a:xfrm>
+          <a:prstGeom prst="rect">
+            <a:avLst/>
+          </a:prstGeom>
+          <a:noFill/>
+          <a:ln/>
+        </p:spPr>
+        <p:txBody>
+          <a:bodyPr wrap="square" lIns="0" tIns="0" rIns="0" bIns="0" rtlCol="0" anchor="ctr"/>
+          <a:lstStyle/>
+          <a:p>
+            <a:pPr indent="0" marL="0">
+              <a:buNone/>
+            </a:pPr>
+            <a:r>
+              <a:rPr lang="en-US" sz="1600" b="1" dirty="0">
+                <a:solidFill>
+                  <a:srgbClr val="0B1F3A"/>
+                </a:solidFill>
+                <a:latin typeface="Georgia" pitchFamily="34" charset="0"/>
+                <a:ea typeface="Georgia" pitchFamily="34" charset="-122"/>
+                <a:cs typeface="Georgia" pitchFamily="34" charset="-120"/>
+              </a:rPr>
+              <a:t>Standard</a:t>
+            </a:r>
+            <a:endParaRPr lang="en-US" sz="1600" dirty="0"/>
+          </a:p>
+        </p:txBody>
+      </p:sp>
+      <p:sp>
+        <p:nvSpPr>
+          <p:cNvPr id="20" name="Text 18"/>
+          <p:cNvSpPr/>
+          <p:nvPr/>
+        </p:nvSpPr>
+        <p:spPr>
+          <a:xfrm>
+            <a:off x="5257800" y="2624328"/>
+            <a:ext cx="1645920" cy="502920"/>
+          </a:xfrm>
+          <a:prstGeom prst="rect">
+            <a:avLst/>
+          </a:prstGeom>
+          <a:noFill/>
+          <a:ln/>
+        </p:spPr>
+        <p:txBody>
+          <a:bodyPr wrap="square" lIns="0" tIns="0" rIns="0" bIns="0" rtlCol="0" anchor="ctr"/>
+          <a:lstStyle/>
+          <a:p>
+            <a:pPr indent="0" marL="0">
+              <a:buNone/>
+            </a:pPr>
+            <a:r>
+              <a:rPr lang="en-US" sz="2800" b="1" dirty="0">
+                <a:solidFill>
+                  <a:srgbClr val="0B1F3A"/>
+                </a:solidFill>
+                <a:latin typeface="Georgia" pitchFamily="34" charset="0"/>
+                <a:ea typeface="Georgia" pitchFamily="34" charset="-122"/>
+                <a:cs typeface="Georgia" pitchFamily="34" charset="-120"/>
+              </a:rPr>
+              <a:t>$50</a:t>
+            </a:r>
+            <a:pPr indent="0" marL="0">
+              <a:buNone/>
+            </a:pPr>
+            <a:r>
+              <a:rPr lang="en-US" sz="1050" dirty="0">
+                <a:solidFill>
+                  <a:srgbClr val="64748B"/>
+                </a:solidFill>
+                <a:latin typeface="Georgia" pitchFamily="34" charset="0"/>
+                <a:ea typeface="Georgia" pitchFamily="34" charset="-122"/>
+                <a:cs typeface="Georgia" pitchFamily="34" charset="-120"/>
+              </a:rPr>
+              <a:t> / mo</a:t>
+            </a:r>
+            <a:endParaRPr lang="en-US" sz="2800" dirty="0"/>
+          </a:p>
+        </p:txBody>
+      </p:sp>
+      <p:sp>
+        <p:nvSpPr>
+          <p:cNvPr id="21" name="Text 19"/>
+          <p:cNvSpPr/>
+          <p:nvPr/>
+        </p:nvSpPr>
+        <p:spPr>
+          <a:xfrm>
+            <a:off x="5257800" y="3227832"/>
+            <a:ext cx="1645920" cy="320040"/>
+          </a:xfrm>
+          <a:prstGeom prst="rect">
+            <a:avLst/>
+          </a:prstGeom>
+          <a:noFill/>
+          <a:ln/>
+        </p:spPr>
+        <p:txBody>
+          <a:bodyPr wrap="square" lIns="0" tIns="0" rIns="0" bIns="0" rtlCol="0" anchor="ctr"/>
+          <a:lstStyle/>
+          <a:p>
+            <a:pPr indent="0" marL="0">
+              <a:buNone/>
+            </a:pPr>
+            <a:r>
+              <a:rPr lang="en-US" sz="1050" b="1" dirty="0">
+                <a:solidFill>
+                  <a:srgbClr val="0F5F5C"/>
+                </a:solidFill>
+                <a:latin typeface="Calibri" pitchFamily="34" charset="0"/>
+                <a:ea typeface="Calibri" pitchFamily="34" charset="-122"/>
+                <a:cs typeface="Calibri" pitchFamily="34" charset="-120"/>
+              </a:rPr>
+              <a:t>10 signed docs / mo</a:t>
+            </a:r>
+            <a:endParaRPr lang="en-US" sz="1050" dirty="0"/>
+          </a:p>
+        </p:txBody>
+      </p:sp>
+      <p:sp>
+        <p:nvSpPr>
+          <p:cNvPr id="22" name="Text 20"/>
+          <p:cNvSpPr/>
+          <p:nvPr/>
+        </p:nvSpPr>
+        <p:spPr>
+          <a:xfrm>
+            <a:off x="5257800" y="3611880"/>
+            <a:ext cx="1645920" cy="1737360"/>
+          </a:xfrm>
+          <a:prstGeom prst="rect">
+            <a:avLst/>
+          </a:prstGeom>
+          <a:noFill/>
+          <a:ln/>
+        </p:spPr>
+        <p:txBody>
+          <a:bodyPr wrap="square" lIns="0" tIns="0" rIns="0" bIns="0" rtlCol="0" anchor="ctr"/>
+          <a:lstStyle/>
+          <a:p>
+            <a:pPr marL="152400" indent="-152400">
+              <a:spcAft>
+                <a:spcPts val="400"/>
+              </a:spcAft>
+              <a:buSzPct val="100000"/>
+              <a:buChar char="✓"/>
+            </a:pPr>
+            <a:r>
+              <a:rPr lang="en-US" sz="1050" dirty="0">
+                <a:solidFill>
+                  <a:srgbClr val="1E293B"/>
+                </a:solidFill>
+                <a:latin typeface="Calibri" pitchFamily="34" charset="0"/>
+                <a:ea typeface="Calibri" pitchFamily="34" charset="-122"/>
+                <a:cs typeface="Calibri" pitchFamily="34" charset="-120"/>
+              </a:rPr>
+              <a:t>2 users</a:t>
+            </a:r>
+            <a:endParaRPr lang="en-US" sz="1050" dirty="0"/>
+          </a:p>
+          <a:p>
+            <a:pPr marL="152400" indent="-152400">
+              <a:spcAft>
+                <a:spcPts val="400"/>
+              </a:spcAft>
+              <a:buSzPct val="100000"/>
+              <a:buChar char="✓"/>
+            </a:pPr>
+            <a:r>
+              <a:rPr lang="en-US" sz="1050" dirty="0">
+                <a:solidFill>
+                  <a:srgbClr val="1E293B"/>
+                </a:solidFill>
+                <a:latin typeface="Calibri" pitchFamily="34" charset="0"/>
+                <a:ea typeface="Calibri" pitchFamily="34" charset="-122"/>
+                <a:cs typeface="Calibri" pitchFamily="34" charset="-120"/>
+              </a:rPr>
+              <a:t>$3 / extra doc</a:t>
+            </a:r>
+            <a:endParaRPr lang="en-US" sz="1050" dirty="0"/>
+          </a:p>
+          <a:p>
+            <a:pPr marL="152400" indent="-152400">
+              <a:spcAft>
+                <a:spcPts val="400"/>
+              </a:spcAft>
+              <a:buSzPct val="100000"/>
+              <a:buChar char="✓"/>
+            </a:pPr>
+            <a:r>
+              <a:rPr lang="en-US" sz="1050" dirty="0">
+                <a:solidFill>
+                  <a:srgbClr val="1E293B"/>
+                </a:solidFill>
+                <a:latin typeface="Calibri" pitchFamily="34" charset="0"/>
+                <a:ea typeface="Calibri" pitchFamily="34" charset="-122"/>
+                <a:cs typeface="Calibri" pitchFamily="34" charset="-120"/>
+              </a:rPr>
+              <a:t>Everything in Starter</a:t>
+            </a:r>
+            <a:endParaRPr lang="en-US" sz="1050" dirty="0"/>
+          </a:p>
+        </p:txBody>
+      </p:sp>
+      <p:sp>
+        <p:nvSpPr>
+          <p:cNvPr id="23" name="Shape 21"/>
+          <p:cNvSpPr/>
+          <p:nvPr/>
+        </p:nvSpPr>
+        <p:spPr>
+          <a:xfrm>
+            <a:off x="7370064" y="1783080"/>
+            <a:ext cx="2011680" cy="3977640"/>
           </a:xfrm>
           <a:prstGeom prst="rect">
             <a:avLst/>
@@ -6824,14 +7092,14 @@
       </p:sp>
       <p:sp>
         <p:nvSpPr>
-          <p:cNvPr id="18" name="Text 16"/>
-          <p:cNvSpPr/>
-          <p:nvPr/>
-        </p:nvSpPr>
-        <p:spPr>
-          <a:xfrm>
-            <a:off x="6400800" y="1965960"/>
-            <a:ext cx="2606040" cy="274320"/>
+          <p:cNvPr id="24" name="Text 22"/>
+          <p:cNvSpPr/>
+          <p:nvPr/>
+        </p:nvSpPr>
+        <p:spPr>
+          <a:xfrm>
+            <a:off x="7370064" y="1947672"/>
+            <a:ext cx="2011680" cy="274320"/>
           </a:xfrm>
           <a:prstGeom prst="rect">
             <a:avLst/>
@@ -6847,7 +7115,7 @@
               <a:buNone/>
             </a:pPr>
             <a:r>
-              <a:rPr lang="en-US" sz="1000" b="1" spc="200" kern="0" dirty="0">
+              <a:rPr lang="en-US" sz="900" b="1" spc="150" kern="0" dirty="0">
                 <a:solidFill>
                   <a:srgbClr val="5EEAD4"/>
                 </a:solidFill>
@@ -6857,36 +7125,36 @@
               </a:rPr>
               <a:t>MOST POPULAR</a:t>
             </a:r>
-            <a:endParaRPr lang="en-US" sz="1000" dirty="0"/>
-          </a:p>
-        </p:txBody>
-      </p:sp>
-      <p:sp>
-        <p:nvSpPr>
-          <p:cNvPr id="19" name="Text 17"/>
-          <p:cNvSpPr/>
-          <p:nvPr/>
-        </p:nvSpPr>
-        <p:spPr>
-          <a:xfrm>
-            <a:off x="6629400" y="2313432"/>
-            <a:ext cx="2194560" cy="365760"/>
-          </a:xfrm>
-          <a:prstGeom prst="rect">
-            <a:avLst/>
-          </a:prstGeom>
-          <a:noFill/>
-          <a:ln/>
-        </p:spPr>
-        <p:txBody>
-          <a:bodyPr wrap="square" lIns="0" tIns="0" rIns="0" bIns="0" rtlCol="0" anchor="ctr"/>
-          <a:lstStyle/>
-          <a:p>
-            <a:pPr indent="0" marL="0">
-              <a:buNone/>
-            </a:pPr>
-            <a:r>
-              <a:rPr lang="en-US" sz="1800" b="1" dirty="0">
+            <a:endParaRPr lang="en-US" sz="900" dirty="0"/>
+          </a:p>
+        </p:txBody>
+      </p:sp>
+      <p:sp>
+        <p:nvSpPr>
+          <p:cNvPr id="25" name="Text 23"/>
+          <p:cNvSpPr/>
+          <p:nvPr/>
+        </p:nvSpPr>
+        <p:spPr>
+          <a:xfrm>
+            <a:off x="7552944" y="2286000"/>
+            <a:ext cx="1645920" cy="365760"/>
+          </a:xfrm>
+          <a:prstGeom prst="rect">
+            <a:avLst/>
+          </a:prstGeom>
+          <a:noFill/>
+          <a:ln/>
+        </p:spPr>
+        <p:txBody>
+          <a:bodyPr wrap="square" lIns="0" tIns="0" rIns="0" bIns="0" rtlCol="0" anchor="ctr"/>
+          <a:lstStyle/>
+          <a:p>
+            <a:pPr indent="0" marL="0">
+              <a:buNone/>
+            </a:pPr>
+            <a:r>
+              <a:rPr lang="en-US" sz="1600" b="1" dirty="0">
                 <a:solidFill>
                   <a:srgbClr val="FFFFFF"/>
                 </a:solidFill>
@@ -6894,38 +7162,38 @@
                 <a:ea typeface="Georgia" pitchFamily="34" charset="-122"/>
                 <a:cs typeface="Georgia" pitchFamily="34" charset="-120"/>
               </a:rPr>
-              <a:t>Team</a:t>
-            </a:r>
-            <a:endParaRPr lang="en-US" sz="1800" dirty="0"/>
-          </a:p>
-        </p:txBody>
-      </p:sp>
-      <p:sp>
-        <p:nvSpPr>
-          <p:cNvPr id="20" name="Text 18"/>
-          <p:cNvSpPr/>
-          <p:nvPr/>
-        </p:nvSpPr>
-        <p:spPr>
-          <a:xfrm>
-            <a:off x="6629400" y="2724912"/>
-            <a:ext cx="2286000" cy="548640"/>
-          </a:xfrm>
-          <a:prstGeom prst="rect">
-            <a:avLst/>
-          </a:prstGeom>
-          <a:noFill/>
-          <a:ln/>
-        </p:spPr>
-        <p:txBody>
-          <a:bodyPr wrap="square" lIns="0" tIns="0" rIns="0" bIns="0" rtlCol="0" anchor="ctr"/>
-          <a:lstStyle/>
-          <a:p>
-            <a:pPr indent="0" marL="0">
-              <a:buNone/>
-            </a:pPr>
-            <a:r>
-              <a:rPr lang="en-US" sz="3400" b="1" dirty="0">
+              <a:t>Pro</a:t>
+            </a:r>
+            <a:endParaRPr lang="en-US" sz="1600" dirty="0"/>
+          </a:p>
+        </p:txBody>
+      </p:sp>
+      <p:sp>
+        <p:nvSpPr>
+          <p:cNvPr id="26" name="Text 24"/>
+          <p:cNvSpPr/>
+          <p:nvPr/>
+        </p:nvSpPr>
+        <p:spPr>
+          <a:xfrm>
+            <a:off x="7552944" y="2670048"/>
+            <a:ext cx="1645920" cy="502920"/>
+          </a:xfrm>
+          <a:prstGeom prst="rect">
+            <a:avLst/>
+          </a:prstGeom>
+          <a:noFill/>
+          <a:ln/>
+        </p:spPr>
+        <p:txBody>
+          <a:bodyPr wrap="square" lIns="0" tIns="0" rIns="0" bIns="0" rtlCol="0" anchor="ctr"/>
+          <a:lstStyle/>
+          <a:p>
+            <a:pPr indent="0" marL="0">
+              <a:buNone/>
+            </a:pPr>
+            <a:r>
+              <a:rPr lang="en-US" sz="2800" b="1" dirty="0">
                 <a:solidFill>
                   <a:srgbClr val="FFFFFF"/>
                 </a:solidFill>
@@ -6933,13 +7201,13 @@
                 <a:ea typeface="Georgia" pitchFamily="34" charset="-122"/>
                 <a:cs typeface="Georgia" pitchFamily="34" charset="-120"/>
               </a:rPr>
-              <a:t>$79</a:t>
-            </a:r>
-            <a:pPr indent="0" marL="0">
-              <a:buNone/>
-            </a:pPr>
-            <a:r>
-              <a:rPr lang="en-US" sz="1200" dirty="0">
+              <a:t>$80</a:t>
+            </a:r>
+            <a:pPr indent="0" marL="0">
+              <a:buNone/>
+            </a:pPr>
+            <a:r>
+              <a:rPr lang="en-US" sz="1050" dirty="0">
                 <a:solidFill>
                   <a:srgbClr val="94A3B8"/>
                 </a:solidFill>
@@ -6949,36 +7217,36 @@
               </a:rPr>
               <a:t> / mo</a:t>
             </a:r>
-            <a:endParaRPr lang="en-US" sz="3400" dirty="0"/>
-          </a:p>
-        </p:txBody>
-      </p:sp>
-      <p:sp>
-        <p:nvSpPr>
-          <p:cNvPr id="21" name="Text 19"/>
-          <p:cNvSpPr/>
-          <p:nvPr/>
-        </p:nvSpPr>
-        <p:spPr>
-          <a:xfrm>
-            <a:off x="6629400" y="3364992"/>
-            <a:ext cx="2240280" cy="320040"/>
-          </a:xfrm>
-          <a:prstGeom prst="rect">
-            <a:avLst/>
-          </a:prstGeom>
-          <a:noFill/>
-          <a:ln/>
-        </p:spPr>
-        <p:txBody>
-          <a:bodyPr wrap="square" lIns="0" tIns="0" rIns="0" bIns="0" rtlCol="0" anchor="ctr"/>
-          <a:lstStyle/>
-          <a:p>
-            <a:pPr indent="0" marL="0">
-              <a:buNone/>
-            </a:pPr>
-            <a:r>
-              <a:rPr lang="en-US" sz="1150" b="1" dirty="0">
+            <a:endParaRPr lang="en-US" sz="2800" dirty="0"/>
+          </a:p>
+        </p:txBody>
+      </p:sp>
+      <p:sp>
+        <p:nvSpPr>
+          <p:cNvPr id="27" name="Text 25"/>
+          <p:cNvSpPr/>
+          <p:nvPr/>
+        </p:nvSpPr>
+        <p:spPr>
+          <a:xfrm>
+            <a:off x="7552944" y="3273552"/>
+            <a:ext cx="1645920" cy="320040"/>
+          </a:xfrm>
+          <a:prstGeom prst="rect">
+            <a:avLst/>
+          </a:prstGeom>
+          <a:noFill/>
+          <a:ln/>
+        </p:spPr>
+        <p:txBody>
+          <a:bodyPr wrap="square" lIns="0" tIns="0" rIns="0" bIns="0" rtlCol="0" anchor="ctr"/>
+          <a:lstStyle/>
+          <a:p>
+            <a:pPr indent="0" marL="0">
+              <a:buNone/>
+            </a:pPr>
+            <a:r>
+              <a:rPr lang="en-US" sz="1050" b="1" dirty="0">
                 <a:solidFill>
                   <a:srgbClr val="5EEAD4"/>
                 </a:solidFill>
@@ -6986,42 +7254,42 @@
                 <a:ea typeface="Calibri" pitchFamily="34" charset="-122"/>
                 <a:cs typeface="Calibri" pitchFamily="34" charset="-120"/>
               </a:rPr>
-              <a:t>50 signed docs included</a:t>
-            </a:r>
-            <a:endParaRPr lang="en-US" sz="1150" dirty="0"/>
-          </a:p>
-        </p:txBody>
-      </p:sp>
-      <p:sp>
-        <p:nvSpPr>
-          <p:cNvPr id="22" name="Text 20"/>
-          <p:cNvSpPr/>
-          <p:nvPr/>
-        </p:nvSpPr>
-        <p:spPr>
-          <a:xfrm>
-            <a:off x="6629400" y="3730752"/>
-            <a:ext cx="2286000" cy="1554480"/>
-          </a:xfrm>
-          <a:prstGeom prst="rect">
-            <a:avLst/>
-          </a:prstGeom>
-          <a:noFill/>
-          <a:ln/>
-        </p:spPr>
-        <p:txBody>
-          <a:bodyPr wrap="square" lIns="0" tIns="0" rIns="0" bIns="0" rtlCol="0" anchor="ctr"/>
-          <a:lstStyle/>
-          <a:p>
-            <a:pPr marL="177800" indent="-177800">
+              <a:t>25 signed docs / mo</a:t>
+            </a:r>
+            <a:endParaRPr lang="en-US" sz="1050" dirty="0"/>
+          </a:p>
+        </p:txBody>
+      </p:sp>
+      <p:sp>
+        <p:nvSpPr>
+          <p:cNvPr id="28" name="Text 26"/>
+          <p:cNvSpPr/>
+          <p:nvPr/>
+        </p:nvSpPr>
+        <p:spPr>
+          <a:xfrm>
+            <a:off x="7552944" y="3657600"/>
+            <a:ext cx="1645920" cy="1737360"/>
+          </a:xfrm>
+          <a:prstGeom prst="rect">
+            <a:avLst/>
+          </a:prstGeom>
+          <a:noFill/>
+          <a:ln/>
+        </p:spPr>
+        <p:txBody>
+          <a:bodyPr wrap="square" lIns="0" tIns="0" rIns="0" bIns="0" rtlCol="0" anchor="ctr"/>
+          <a:lstStyle/>
+          <a:p>
+            <a:pPr marL="152400" indent="-152400">
               <a:spcAft>
-                <a:spcPts val="500"/>
+                <a:spcPts val="400"/>
               </a:spcAft>
               <a:buSzPct val="100000"/>
               <a:buChar char="✓"/>
             </a:pPr>
             <a:r>
-              <a:rPr lang="en-US" sz="1150" dirty="0">
+              <a:rPr lang="en-US" sz="1050" dirty="0">
                 <a:solidFill>
                   <a:srgbClr val="CBD5E1"/>
                 </a:solidFill>
@@ -7029,20 +7297,20 @@
                 <a:ea typeface="Calibri" pitchFamily="34" charset="-122"/>
                 <a:cs typeface="Calibri" pitchFamily="34" charset="-120"/>
               </a:rPr>
-              <a:t>5 users · up to 10</a:t>
-            </a:r>
-            <a:endParaRPr lang="en-US" sz="1150" dirty="0"/>
-          </a:p>
-          <a:p>
-            <a:pPr marL="177800" indent="-177800">
+              <a:t>5 users</a:t>
+            </a:r>
+            <a:endParaRPr lang="en-US" sz="1050" dirty="0"/>
+          </a:p>
+          <a:p>
+            <a:pPr marL="152400" indent="-152400">
               <a:spcAft>
-                <a:spcPts val="500"/>
+                <a:spcPts val="400"/>
               </a:spcAft>
               <a:buSzPct val="100000"/>
               <a:buChar char="✓"/>
             </a:pPr>
             <a:r>
-              <a:rPr lang="en-US" sz="1150" dirty="0">
+              <a:rPr lang="en-US" sz="1050" dirty="0">
                 <a:solidFill>
                   <a:srgbClr val="CBD5E1"/>
                 </a:solidFill>
@@ -7050,20 +7318,20 @@
                 <a:ea typeface="Calibri" pitchFamily="34" charset="-122"/>
                 <a:cs typeface="Calibri" pitchFamily="34" charset="-120"/>
               </a:rPr>
-              <a:t>+$10/seat (+5 docs)</a:t>
-            </a:r>
-            <a:endParaRPr lang="en-US" sz="1150" dirty="0"/>
-          </a:p>
-          <a:p>
-            <a:pPr marL="177800" indent="-177800">
+              <a:t>$3 / extra doc</a:t>
+            </a:r>
+            <a:endParaRPr lang="en-US" sz="1050" dirty="0"/>
+          </a:p>
+          <a:p>
+            <a:pPr marL="152400" indent="-152400">
               <a:spcAft>
-                <a:spcPts val="500"/>
+                <a:spcPts val="400"/>
               </a:spcAft>
               <a:buSzPct val="100000"/>
               <a:buChar char="✓"/>
             </a:pPr>
             <a:r>
-              <a:rPr lang="en-US" sz="1150" dirty="0">
+              <a:rPr lang="en-US" sz="1050" dirty="0">
                 <a:solidFill>
                   <a:srgbClr val="CBD5E1"/>
                 </a:solidFill>
@@ -7071,43 +7339,22 @@
                 <a:ea typeface="Calibri" pitchFamily="34" charset="-122"/>
                 <a:cs typeface="Calibri" pitchFamily="34" charset="-120"/>
               </a:rPr>
-              <a:t>$3 per extra doc</a:t>
-            </a:r>
-            <a:endParaRPr lang="en-US" sz="1150" dirty="0"/>
-          </a:p>
-          <a:p>
-            <a:pPr marL="177800" indent="-177800">
-              <a:spcAft>
-                <a:spcPts val="500"/>
-              </a:spcAft>
-              <a:buSzPct val="100000"/>
-              <a:buChar char="✓"/>
-            </a:pPr>
-            <a:r>
-              <a:rPr lang="en-US" sz="1150" dirty="0">
-                <a:solidFill>
-                  <a:srgbClr val="CBD5E1"/>
-                </a:solidFill>
-                <a:latin typeface="Calibri" pitchFamily="34" charset="0"/>
-                <a:ea typeface="Calibri" pitchFamily="34" charset="-122"/>
-                <a:cs typeface="Calibri" pitchFamily="34" charset="-120"/>
-              </a:rPr>
-              <a:t>Everything in Starter</a:t>
-            </a:r>
-            <a:endParaRPr lang="en-US" sz="1150" dirty="0"/>
-          </a:p>
-        </p:txBody>
-      </p:sp>
-      <p:sp>
-        <p:nvSpPr>
-          <p:cNvPr id="23" name="Shape 21"/>
-          <p:cNvSpPr/>
-          <p:nvPr/>
-        </p:nvSpPr>
-        <p:spPr>
-          <a:xfrm>
-            <a:off x="9189720" y="1920240"/>
-            <a:ext cx="2606040" cy="3566160"/>
+              <a:t>Everything in Standard</a:t>
+            </a:r>
+            <a:endParaRPr lang="en-US" sz="1050" dirty="0"/>
+          </a:p>
+        </p:txBody>
+      </p:sp>
+      <p:sp>
+        <p:nvSpPr>
+          <p:cNvPr id="29" name="Shape 27"/>
+          <p:cNvSpPr/>
+          <p:nvPr/>
+        </p:nvSpPr>
+        <p:spPr>
+          <a:xfrm>
+            <a:off x="9665208" y="1965960"/>
+            <a:ext cx="2011680" cy="3657600"/>
           </a:xfrm>
           <a:prstGeom prst="rect">
             <a:avLst/>
@@ -7132,14 +7379,14 @@
       </p:sp>
       <p:sp>
         <p:nvSpPr>
-          <p:cNvPr id="24" name="Shape 22"/>
-          <p:cNvSpPr/>
-          <p:nvPr/>
-        </p:nvSpPr>
-        <p:spPr>
-          <a:xfrm>
-            <a:off x="9189720" y="1920240"/>
-            <a:ext cx="2606040" cy="73152"/>
+          <p:cNvPr id="30" name="Shape 28"/>
+          <p:cNvSpPr/>
+          <p:nvPr/>
+        </p:nvSpPr>
+        <p:spPr>
+          <a:xfrm>
+            <a:off x="9665208" y="1965960"/>
+            <a:ext cx="2011680" cy="73152"/>
           </a:xfrm>
           <a:prstGeom prst="rect">
             <a:avLst/>
@@ -7152,30 +7399,30 @@
       </p:sp>
       <p:sp>
         <p:nvSpPr>
-          <p:cNvPr id="25" name="Text 23"/>
-          <p:cNvSpPr/>
-          <p:nvPr/>
-        </p:nvSpPr>
-        <p:spPr>
-          <a:xfrm>
-            <a:off x="9418320" y="2212848"/>
-            <a:ext cx="2194560" cy="365760"/>
-          </a:xfrm>
-          <a:prstGeom prst="rect">
-            <a:avLst/>
-          </a:prstGeom>
-          <a:noFill/>
-          <a:ln/>
-        </p:spPr>
-        <p:txBody>
-          <a:bodyPr wrap="square" lIns="0" tIns="0" rIns="0" bIns="0" rtlCol="0" anchor="ctr"/>
-          <a:lstStyle/>
-          <a:p>
-            <a:pPr indent="0" marL="0">
-              <a:buNone/>
-            </a:pPr>
-            <a:r>
-              <a:rPr lang="en-US" sz="1800" b="1" dirty="0">
+          <p:cNvPr id="31" name="Text 29"/>
+          <p:cNvSpPr/>
+          <p:nvPr/>
+        </p:nvSpPr>
+        <p:spPr>
+          <a:xfrm>
+            <a:off x="9848088" y="2240280"/>
+            <a:ext cx="1645920" cy="365760"/>
+          </a:xfrm>
+          <a:prstGeom prst="rect">
+            <a:avLst/>
+          </a:prstGeom>
+          <a:noFill/>
+          <a:ln/>
+        </p:spPr>
+        <p:txBody>
+          <a:bodyPr wrap="square" lIns="0" tIns="0" rIns="0" bIns="0" rtlCol="0" anchor="ctr"/>
+          <a:lstStyle/>
+          <a:p>
+            <a:pPr indent="0" marL="0">
+              <a:buNone/>
+            </a:pPr>
+            <a:r>
+              <a:rPr lang="en-US" sz="1600" b="1" dirty="0">
                 <a:solidFill>
                   <a:srgbClr val="0B1F3A"/>
                 </a:solidFill>
@@ -7183,38 +7430,38 @@
                 <a:ea typeface="Georgia" pitchFamily="34" charset="-122"/>
                 <a:cs typeface="Georgia" pitchFamily="34" charset="-120"/>
               </a:rPr>
-              <a:t>Team Ultra</a:t>
-            </a:r>
-            <a:endParaRPr lang="en-US" sz="1800" dirty="0"/>
-          </a:p>
-        </p:txBody>
-      </p:sp>
-      <p:sp>
-        <p:nvSpPr>
-          <p:cNvPr id="26" name="Text 24"/>
-          <p:cNvSpPr/>
-          <p:nvPr/>
-        </p:nvSpPr>
-        <p:spPr>
-          <a:xfrm>
-            <a:off x="9418320" y="2624328"/>
-            <a:ext cx="2286000" cy="548640"/>
-          </a:xfrm>
-          <a:prstGeom prst="rect">
-            <a:avLst/>
-          </a:prstGeom>
-          <a:noFill/>
-          <a:ln/>
-        </p:spPr>
-        <p:txBody>
-          <a:bodyPr wrap="square" lIns="0" tIns="0" rIns="0" bIns="0" rtlCol="0" anchor="ctr"/>
-          <a:lstStyle/>
-          <a:p>
-            <a:pPr indent="0" marL="0">
-              <a:buNone/>
-            </a:pPr>
-            <a:r>
-              <a:rPr lang="en-US" sz="3400" b="1" dirty="0">
+              <a:t>Ultra</a:t>
+            </a:r>
+            <a:endParaRPr lang="en-US" sz="1600" dirty="0"/>
+          </a:p>
+        </p:txBody>
+      </p:sp>
+      <p:sp>
+        <p:nvSpPr>
+          <p:cNvPr id="32" name="Text 30"/>
+          <p:cNvSpPr/>
+          <p:nvPr/>
+        </p:nvSpPr>
+        <p:spPr>
+          <a:xfrm>
+            <a:off x="9848088" y="2624328"/>
+            <a:ext cx="1645920" cy="502920"/>
+          </a:xfrm>
+          <a:prstGeom prst="rect">
+            <a:avLst/>
+          </a:prstGeom>
+          <a:noFill/>
+          <a:ln/>
+        </p:spPr>
+        <p:txBody>
+          <a:bodyPr wrap="square" lIns="0" tIns="0" rIns="0" bIns="0" rtlCol="0" anchor="ctr"/>
+          <a:lstStyle/>
+          <a:p>
+            <a:pPr indent="0" marL="0">
+              <a:buNone/>
+            </a:pPr>
+            <a:r>
+              <a:rPr lang="en-US" sz="2800" b="1" dirty="0">
                 <a:solidFill>
                   <a:srgbClr val="0B1F3A"/>
                 </a:solidFill>
@@ -7222,13 +7469,13 @@
                 <a:ea typeface="Georgia" pitchFamily="34" charset="-122"/>
                 <a:cs typeface="Georgia" pitchFamily="34" charset="-120"/>
               </a:rPr>
-              <a:t>$159</a:t>
-            </a:r>
-            <a:pPr indent="0" marL="0">
-              <a:buNone/>
-            </a:pPr>
-            <a:r>
-              <a:rPr lang="en-US" sz="1200" dirty="0">
+              <a:t>$150</a:t>
+            </a:r>
+            <a:pPr indent="0" marL="0">
+              <a:buNone/>
+            </a:pPr>
+            <a:r>
+              <a:rPr lang="en-US" sz="1050" dirty="0">
                 <a:solidFill>
                   <a:srgbClr val="64748B"/>
                 </a:solidFill>
@@ -7238,36 +7485,36 @@
               </a:rPr>
               <a:t> / mo</a:t>
             </a:r>
-            <a:endParaRPr lang="en-US" sz="3400" dirty="0"/>
-          </a:p>
-        </p:txBody>
-      </p:sp>
-      <p:sp>
-        <p:nvSpPr>
-          <p:cNvPr id="27" name="Text 25"/>
-          <p:cNvSpPr/>
-          <p:nvPr/>
-        </p:nvSpPr>
-        <p:spPr>
-          <a:xfrm>
-            <a:off x="9418320" y="3264408"/>
-            <a:ext cx="2240280" cy="320040"/>
-          </a:xfrm>
-          <a:prstGeom prst="rect">
-            <a:avLst/>
-          </a:prstGeom>
-          <a:noFill/>
-          <a:ln/>
-        </p:spPr>
-        <p:txBody>
-          <a:bodyPr wrap="square" lIns="0" tIns="0" rIns="0" bIns="0" rtlCol="0" anchor="ctr"/>
-          <a:lstStyle/>
-          <a:p>
-            <a:pPr indent="0" marL="0">
-              <a:buNone/>
-            </a:pPr>
-            <a:r>
-              <a:rPr lang="en-US" sz="1150" b="1" dirty="0">
+            <a:endParaRPr lang="en-US" sz="2800" dirty="0"/>
+          </a:p>
+        </p:txBody>
+      </p:sp>
+      <p:sp>
+        <p:nvSpPr>
+          <p:cNvPr id="33" name="Text 31"/>
+          <p:cNvSpPr/>
+          <p:nvPr/>
+        </p:nvSpPr>
+        <p:spPr>
+          <a:xfrm>
+            <a:off x="9848088" y="3227832"/>
+            <a:ext cx="1645920" cy="320040"/>
+          </a:xfrm>
+          <a:prstGeom prst="rect">
+            <a:avLst/>
+          </a:prstGeom>
+          <a:noFill/>
+          <a:ln/>
+        </p:spPr>
+        <p:txBody>
+          <a:bodyPr wrap="square" lIns="0" tIns="0" rIns="0" bIns="0" rtlCol="0" anchor="ctr"/>
+          <a:lstStyle/>
+          <a:p>
+            <a:pPr indent="0" marL="0">
+              <a:buNone/>
+            </a:pPr>
+            <a:r>
+              <a:rPr lang="en-US" sz="1050" b="1" dirty="0">
                 <a:solidFill>
                   <a:srgbClr val="0F5F5C"/>
                 </a:solidFill>
@@ -7275,42 +7522,42 @@
                 <a:ea typeface="Calibri" pitchFamily="34" charset="-122"/>
                 <a:cs typeface="Calibri" pitchFamily="34" charset="-120"/>
               </a:rPr>
-              <a:t>100 signed docs included</a:t>
-            </a:r>
-            <a:endParaRPr lang="en-US" sz="1150" dirty="0"/>
-          </a:p>
-        </p:txBody>
-      </p:sp>
-      <p:sp>
-        <p:nvSpPr>
-          <p:cNvPr id="28" name="Text 26"/>
-          <p:cNvSpPr/>
-          <p:nvPr/>
-        </p:nvSpPr>
-        <p:spPr>
-          <a:xfrm>
-            <a:off x="9418320" y="3630168"/>
-            <a:ext cx="2286000" cy="1554480"/>
-          </a:xfrm>
-          <a:prstGeom prst="rect">
-            <a:avLst/>
-          </a:prstGeom>
-          <a:noFill/>
-          <a:ln/>
-        </p:spPr>
-        <p:txBody>
-          <a:bodyPr wrap="square" lIns="0" tIns="0" rIns="0" bIns="0" rtlCol="0" anchor="ctr"/>
-          <a:lstStyle/>
-          <a:p>
-            <a:pPr marL="177800" indent="-177800">
+              <a:t>50 signed docs / mo</a:t>
+            </a:r>
+            <a:endParaRPr lang="en-US" sz="1050" dirty="0"/>
+          </a:p>
+        </p:txBody>
+      </p:sp>
+      <p:sp>
+        <p:nvSpPr>
+          <p:cNvPr id="34" name="Text 32"/>
+          <p:cNvSpPr/>
+          <p:nvPr/>
+        </p:nvSpPr>
+        <p:spPr>
+          <a:xfrm>
+            <a:off x="9848088" y="3611880"/>
+            <a:ext cx="1645920" cy="1737360"/>
+          </a:xfrm>
+          <a:prstGeom prst="rect">
+            <a:avLst/>
+          </a:prstGeom>
+          <a:noFill/>
+          <a:ln/>
+        </p:spPr>
+        <p:txBody>
+          <a:bodyPr wrap="square" lIns="0" tIns="0" rIns="0" bIns="0" rtlCol="0" anchor="ctr"/>
+          <a:lstStyle/>
+          <a:p>
+            <a:pPr marL="152400" indent="-152400">
               <a:spcAft>
-                <a:spcPts val="500"/>
+                <a:spcPts val="400"/>
               </a:spcAft>
               <a:buSzPct val="100000"/>
               <a:buChar char="✓"/>
             </a:pPr>
             <a:r>
-              <a:rPr lang="en-US" sz="1150" dirty="0">
+              <a:rPr lang="en-US" sz="1050" dirty="0">
                 <a:solidFill>
                   <a:srgbClr val="1E293B"/>
                 </a:solidFill>
@@ -7318,20 +7565,20 @@
                 <a:ea typeface="Calibri" pitchFamily="34" charset="-122"/>
                 <a:cs typeface="Calibri" pitchFamily="34" charset="-120"/>
               </a:rPr>
-              <a:t>10 users included</a:t>
-            </a:r>
-            <a:endParaRPr lang="en-US" sz="1150" dirty="0"/>
-          </a:p>
-          <a:p>
-            <a:pPr marL="177800" indent="-177800">
+              <a:t>10 users</a:t>
+            </a:r>
+            <a:endParaRPr lang="en-US" sz="1050" dirty="0"/>
+          </a:p>
+          <a:p>
+            <a:pPr marL="152400" indent="-152400">
               <a:spcAft>
-                <a:spcPts val="500"/>
+                <a:spcPts val="400"/>
               </a:spcAft>
               <a:buSzPct val="100000"/>
               <a:buChar char="✓"/>
             </a:pPr>
             <a:r>
-              <a:rPr lang="en-US" sz="1150" dirty="0">
+              <a:rPr lang="en-US" sz="1050" dirty="0">
                 <a:solidFill>
                   <a:srgbClr val="1E293B"/>
                 </a:solidFill>
@@ -7339,20 +7586,20 @@
                 <a:ea typeface="Calibri" pitchFamily="34" charset="-122"/>
                 <a:cs typeface="Calibri" pitchFamily="34" charset="-120"/>
               </a:rPr>
-              <a:t>$3 per extra doc</a:t>
-            </a:r>
-            <a:endParaRPr lang="en-US" sz="1150" dirty="0"/>
-          </a:p>
-          <a:p>
-            <a:pPr marL="177800" indent="-177800">
+              <a:t>$3 / extra doc</a:t>
+            </a:r>
+            <a:endParaRPr lang="en-US" sz="1050" dirty="0"/>
+          </a:p>
+          <a:p>
+            <a:pPr marL="152400" indent="-152400">
               <a:spcAft>
-                <a:spcPts val="500"/>
+                <a:spcPts val="400"/>
               </a:spcAft>
               <a:buSzPct val="100000"/>
               <a:buChar char="✓"/>
             </a:pPr>
             <a:r>
-              <a:rPr lang="en-US" sz="1150" dirty="0">
+              <a:rPr lang="en-US" sz="1050" dirty="0">
                 <a:solidFill>
                   <a:srgbClr val="1E293B"/>
                 </a:solidFill>
@@ -7362,18 +7609,18 @@
               </a:rPr>
               <a:t>Best per-doc rate</a:t>
             </a:r>
-            <a:endParaRPr lang="en-US" sz="1150" dirty="0"/>
-          </a:p>
-          <a:p>
-            <a:pPr marL="177800" indent="-177800">
+            <a:endParaRPr lang="en-US" sz="1050" dirty="0"/>
+          </a:p>
+          <a:p>
+            <a:pPr marL="152400" indent="-152400">
               <a:spcAft>
-                <a:spcPts val="500"/>
+                <a:spcPts val="400"/>
               </a:spcAft>
               <a:buSzPct val="100000"/>
               <a:buChar char="✓"/>
             </a:pPr>
             <a:r>
-              <a:rPr lang="en-US" sz="1150" dirty="0">
+              <a:rPr lang="en-US" sz="1050" dirty="0">
                 <a:solidFill>
                   <a:srgbClr val="1E293B"/>
                 </a:solidFill>
@@ -7381,21 +7628,21 @@
                 <a:ea typeface="Calibri" pitchFamily="34" charset="-122"/>
                 <a:cs typeface="Calibri" pitchFamily="34" charset="-120"/>
               </a:rPr>
-              <a:t>Everything in Team</a:t>
-            </a:r>
-            <a:endParaRPr lang="en-US" sz="1150" dirty="0"/>
-          </a:p>
-        </p:txBody>
-      </p:sp>
-      <p:sp>
-        <p:nvSpPr>
-          <p:cNvPr id="29" name="Text 27"/>
-          <p:cNvSpPr/>
-          <p:nvPr/>
-        </p:nvSpPr>
-        <p:spPr>
-          <a:xfrm>
-            <a:off x="822960" y="5943600"/>
+              <a:t>Everything in Pro</a:t>
+            </a:r>
+            <a:endParaRPr lang="en-US" sz="1050" dirty="0"/>
+          </a:p>
+        </p:txBody>
+      </p:sp>
+      <p:sp>
+        <p:nvSpPr>
+          <p:cNvPr id="35" name="Text 33"/>
+          <p:cNvSpPr/>
+          <p:nvPr/>
+        </p:nvSpPr>
+        <p:spPr>
+          <a:xfrm>
+            <a:off x="822960" y="5989320"/>
             <a:ext cx="10515600" cy="548640"/>
           </a:xfrm>
           <a:prstGeom prst="rect">
@@ -7412,7 +7659,7 @@
               <a:buNone/>
             </a:pPr>
             <a:r>
-              <a:rPr lang="en-US" sz="1150" i="1" dirty="0">
+              <a:rPr lang="en-US" sz="1100" i="1" dirty="0">
                 <a:solidFill>
                   <a:srgbClr val="64748B"/>
                 </a:solidFill>
@@ -7420,9 +7667,9 @@
                 <a:ea typeface="Calibri" pitchFamily="34" charset="-122"/>
                 <a:cs typeface="Calibri" pitchFamily="34" charset="-120"/>
               </a:rPr>
-              <a:t>Flat $3 per completed document beyond your plan's monthly included docs — any plan, never a hard cap. Annual billing (~2 months free). Pricing is being finalized during beta — contact hello@ultraquote.io.</a:t>
-            </a:r>
-            <a:endParaRPr lang="en-US" sz="1150" dirty="0"/>
+              <a:t>Flat $3 per completed document beyond your plan's monthly included docs — any plan, never a hard cap. Users are fixed per plan (no seat add-ons); AI proposal drafting is included on every plan. Annual billing (~2 months free). Pricing is being finalized during beta — contact hello@ultraquote.io.</a:t>
+            </a:r>
+            <a:endParaRPr lang="en-US" sz="1100" dirty="0"/>
           </a:p>
         </p:txBody>
       </p:sp>

</xml_diff>